<commit_message>
feat: VisionInsight 수동 검사 UI 및 PatchCore·Gemini AI 진단 연동
- React 기반 VisionInsight 대시보드 및 LiveView 구축
- H.264 영상 재생, Pause, Frame Step, 서버 Grab 기능 구현
- ROI 선택·이동·크기 조절 및 Grab 기반 Crop 기능 통합
- 600×600 ImageView에 Zoom, Pan, Pixel Inspector, GV 격자 표시 구현
- 정적 이미지 PatchCore 검사 API 및 검사 이력 조회 UI 연동
- Gemini Agent 저장 보고서, Observed Facts, Evidence 표시 기능 구현
- Gemini 분석 실행 확인 모달 및 오류 처리 개선
- 실제 검사 기록과 테스트 Fixture 구분 및 T06 시나리오 표기 수정
- Vite API 프록시, 관련 테스트 및 기술 문서 보강
</commit_message>
<xml_diff>
--- a/presentation/VisionInsight_Presentation_14slides_verified.pptx
+++ b/presentation/VisionInsight_Presentation_14slides_verified.pptx
@@ -3306,7 +3306,7 @@
               </a:defRPr>
             </a:pPr>
             <a:r>
-              <a:t>검증 완료: 단일 이미지 CPU 추론 평균 42.53ms  |  E2E 실서버 검증 (T01 양품 PASS / T03 경고 PASS)  |  전체 pytest 984 PASS (경고 3건)</a:t>
+              <a:t>검증 완료: 단일 이미지 CPU 추론 평균 42.53ms  |  4대 시나리오 실제 Gemini E2E 성공 (T01/T03/T05/T06 PASS)  |  전체 pytest 1089 PASS / 4 SKIP (경고 2건)</a:t>
             </a:r>
           </a:p>
           <a:p>
@@ -3457,7 +3457,7 @@
               </a:defRPr>
             </a:pPr>
             <a:r>
-              <a:t>실제 Gemini API E2E 검증 결과: T01 정상 및 T03 경고 검증 (PASS)</a:t>
+              <a:t>실제 Gemini API E2E 검증 결과: 4대 대표 시나리오 전원 성공 (PASS)</a:t>
             </a:r>
           </a:p>
         </p:txBody>
@@ -3470,8 +3470,8 @@
         </p:nvSpPr>
         <p:spPr>
           <a:xfrm>
-            <a:off x="731520" y="1280160"/>
-            <a:ext cx="5212080" cy="4846320"/>
+            <a:off x="731520" y="1261872"/>
+            <a:ext cx="2514600" cy="4096512"/>
           </a:xfrm>
           <a:prstGeom prst="roundRect">
             <a:avLst/>
@@ -3515,8 +3515,8 @@
         </p:nvSpPr>
         <p:spPr>
           <a:xfrm>
-            <a:off x="1005840" y="1508760"/>
-            <a:ext cx="4663440" cy="4389120"/>
+            <a:off x="841248" y="1316736"/>
+            <a:ext cx="2295144" cy="3977639"/>
           </a:xfrm>
           <a:prstGeom prst="rect">
             <a:avLst/>
@@ -3530,6 +3530,51 @@
           <a:lstStyle/>
           <a:p>
             <a:pPr>
+              <a:defRPr sz="1800" b="1">
+                <a:solidFill>
+                  <a:srgbClr val="F8FAFC"/>
+                </a:solidFill>
+                <a:latin typeface="Malgun Gothic"/>
+              </a:defRPr>
+            </a:pPr>
+            <a:r>
+              <a:t>T01 정상</a:t>
+            </a:r>
+          </a:p>
+          <a:p>
+            <a:pPr>
+              <a:spcBef>
+                <a:spcPts val="200"/>
+              </a:spcBef>
+              <a:defRPr sz="1250" b="1">
+                <a:solidFill>
+                  <a:srgbClr val="34D399"/>
+                </a:solidFill>
+                <a:latin typeface="Malgun Gothic"/>
+              </a:defRPr>
+            </a:pPr>
+            <a:r>
+              <a:t>✔ E2E PASS (HTTP 200)</a:t>
+            </a:r>
+          </a:p>
+          <a:p>
+            <a:pPr>
+              <a:spcBef>
+                <a:spcPts val="800"/>
+              </a:spcBef>
+              <a:defRPr sz="1100">
+                <a:solidFill>
+                  <a:srgbClr val="94A3B8"/>
+                </a:solidFill>
+                <a:latin typeface="Malgun Gothic"/>
+              </a:defRPr>
+            </a:pPr>
+            <a:r>
+              <a:t>최종 판정</a:t>
+            </a:r>
+          </a:p>
+          <a:p>
+            <a:pPr>
               <a:defRPr sz="1500" b="1">
                 <a:solidFill>
                   <a:srgbClr val="34D399"/>
@@ -3538,15 +3583,12 @@
               </a:defRPr>
             </a:pPr>
             <a:r>
-              <a:t>T01 정상 시나리오: 실서버 E2E 성공 (PASS)</a:t>
-            </a:r>
-          </a:p>
-          <a:p>
-            <a:pPr>
-              <a:spcBef>
-                <a:spcPts val="500"/>
-              </a:spcBef>
-              <a:defRPr sz="1050">
+              <a:t>최종 OK</a:t>
+            </a:r>
+          </a:p>
+          <a:p>
+            <a:pPr>
+              <a:defRPr sz="1000">
                 <a:solidFill>
                   <a:srgbClr val="CBD5E1"/>
                 </a:solidFill>
@@ -3554,47 +3596,73 @@
               </a:defRPr>
             </a:pPr>
             <a:r>
-              <a:t>• 검사 식별자: INSP-001396 (정상 병 검사)</a:t>
-            </a:r>
-          </a:p>
-          <a:p>
-            <a:pPr>
-              <a:spcBef>
-                <a:spcPts val="500"/>
-              </a:spcBef>
-              <a:defRPr sz="1050">
-                <a:solidFill>
-                  <a:srgbClr val="F8FAFC"/>
-                </a:solidFill>
-                <a:latin typeface="Malgun Gothic"/>
-              </a:defRPr>
-            </a:pPr>
-            <a:r>
-              <a:t>• 판정 결과: 모델 OK  /  서버 최종 판정 OK (Rule 5 발급)</a:t>
-            </a:r>
-          </a:p>
-          <a:p>
-            <a:pPr>
-              <a:spcBef>
-                <a:spcPts val="500"/>
-              </a:spcBef>
-              <a:defRPr sz="1050">
-                <a:solidFill>
-                  <a:srgbClr val="F8FAFC"/>
-                </a:solidFill>
-                <a:latin typeface="Malgun Gothic"/>
-              </a:defRPr>
-            </a:pPr>
-            <a:r>
-              <a:t>• FastAPI 응답: HTTP 200 OK  (analysis_status: COMPLETED)</a:t>
-            </a:r>
-          </a:p>
-          <a:p>
-            <a:pPr>
-              <a:spcBef>
-                <a:spcPts val="500"/>
-              </a:spcBef>
-              <a:defRPr sz="1050">
+              <a:t>(모델 OK ➔ Rule 5)</a:t>
+            </a:r>
+          </a:p>
+          <a:p>
+            <a:pPr>
+              <a:spcBef>
+                <a:spcPts val="800"/>
+              </a:spcBef>
+              <a:defRPr sz="1100">
+                <a:solidFill>
+                  <a:srgbClr val="94A3B8"/>
+                </a:solidFill>
+                <a:latin typeface="Malgun Gothic"/>
+              </a:defRPr>
+            </a:pPr>
+            <a:r>
+              <a:t>전체 E2E 소요시간</a:t>
+            </a:r>
+          </a:p>
+          <a:p>
+            <a:pPr>
+              <a:defRPr sz="1700" b="1">
+                <a:solidFill>
+                  <a:srgbClr val="4CD7F6"/>
+                </a:solidFill>
+                <a:latin typeface="Malgun Gothic"/>
+              </a:defRPr>
+            </a:pPr>
+            <a:r>
+              <a:t>13.58초</a:t>
+            </a:r>
+          </a:p>
+          <a:p>
+            <a:pPr>
+              <a:spcBef>
+                <a:spcPts val="800"/>
+              </a:spcBef>
+              <a:defRPr sz="1100">
+                <a:solidFill>
+                  <a:srgbClr val="94A3B8"/>
+                </a:solidFill>
+                <a:latin typeface="Malgun Gothic"/>
+              </a:defRPr>
+            </a:pPr>
+            <a:r>
+              <a:t>검증 Fact (근거)</a:t>
+            </a:r>
+          </a:p>
+          <a:p>
+            <a:pPr>
+              <a:defRPr sz="1350" b="1">
+                <a:solidFill>
+                  <a:srgbClr val="34D399"/>
+                </a:solidFill>
+                <a:latin typeface="Malgun Gothic"/>
+              </a:defRPr>
+            </a:pPr>
+            <a:r>
+              <a:t>Fact 6개 (100% 검증 통과)</a:t>
+            </a:r>
+          </a:p>
+          <a:p>
+            <a:pPr>
+              <a:spcBef>
+                <a:spcPts val="800"/>
+              </a:spcBef>
+              <a:defRPr sz="950">
                 <a:solidFill>
                   <a:srgbClr val="CBD5E1"/>
                 </a:solidFill>
@@ -3602,71 +3670,19 @@
               </a:defRPr>
             </a:pPr>
             <a:r>
-              <a:t>• Gemini 통신: 2회 모두 HTTP 200 성공 (전체 소요: 13.578초)</a:t>
-            </a:r>
-          </a:p>
-          <a:p>
-            <a:pPr>
-              <a:spcBef>
-                <a:spcPts val="500"/>
-              </a:spcBef>
-              <a:defRPr sz="1050">
-                <a:solidFill>
-                  <a:srgbClr val="CBD5E1"/>
-                </a:solidFill>
-                <a:latin typeface="Malgun Gothic"/>
-              </a:defRPr>
-            </a:pPr>
-            <a:r>
-              <a:t>• 토큰 사용량: 총 4,706 토큰 (입력 3,115, 출력 125, Thinking 1,466)</a:t>
-            </a:r>
-          </a:p>
-          <a:p>
-            <a:pPr>
-              <a:spcBef>
-                <a:spcPts val="500"/>
-              </a:spcBef>
-              <a:defRPr sz="1050">
-                <a:solidFill>
-                  <a:srgbClr val="CBD5E1"/>
-                </a:solidFill>
-                <a:latin typeface="Malgun Gothic"/>
-              </a:defRPr>
-            </a:pPr>
-            <a:r>
-              <a:t>• 도구 실행: get_inspection_result 실행 (2.23ms, E0001 발급)</a:t>
-            </a:r>
-          </a:p>
-          <a:p>
-            <a:pPr>
-              <a:spcBef>
-                <a:spcPts val="500"/>
-              </a:spcBef>
-              <a:defRPr sz="1050">
-                <a:solidFill>
-                  <a:srgbClr val="F8FAFC"/>
-                </a:solidFill>
-                <a:latin typeface="Malgun Gothic"/>
-              </a:defRPr>
-            </a:pPr>
-            <a:r>
-              <a:t>• 근거 검증: 관측 사실 6개 (F0001~F0006) 1:1 결정적 검증 100% 통과</a:t>
-            </a:r>
-          </a:p>
-          <a:p>
-            <a:pPr>
-              <a:spcBef>
-                <a:spcPts val="500"/>
-              </a:spcBef>
-              <a:defRPr sz="1050">
-                <a:solidFill>
-                  <a:srgbClr val="CBD5E1"/>
-                </a:solidFill>
-                <a:latin typeface="Malgun Gothic"/>
-              </a:defRPr>
-            </a:pPr>
-            <a:r>
-              <a:t>• 권장 조치: CONTINUE_MONITORING (근거 참조: F0003 앵커링)</a:t>
+              <a:t>• Rule 5 (ALL_CHECKS_PASSED)</a:t>
+            </a:r>
+            <a:br/>
+            <a:r>
+              <a:t>• 도구 1개 / 4,706 토큰</a:t>
+            </a:r>
+            <a:br/>
+            <a:r>
+              <a:t>• 권고: CONTINUE_MONITORING</a:t>
+            </a:r>
+            <a:br/>
+            <a:r>
+              <a:t>• 검사 ID: INSP-001396</a:t>
             </a:r>
           </a:p>
         </p:txBody>
@@ -3679,8 +3695,8 @@
         </p:nvSpPr>
         <p:spPr>
           <a:xfrm>
-            <a:off x="6217920" y="1280160"/>
-            <a:ext cx="5212080" cy="4846320"/>
+            <a:off x="3469233" y="1261872"/>
+            <a:ext cx="2514600" cy="4096512"/>
           </a:xfrm>
           <a:prstGeom prst="roundRect">
             <a:avLst/>
@@ -3724,8 +3740,8 @@
         </p:nvSpPr>
         <p:spPr>
           <a:xfrm>
-            <a:off x="6492240" y="1508760"/>
-            <a:ext cx="4663440" cy="4389120"/>
+            <a:off x="3578961" y="1316736"/>
+            <a:ext cx="2295144" cy="3977639"/>
           </a:xfrm>
           <a:prstGeom prst="rect">
             <a:avLst/>
@@ -3739,22 +3755,289 @@
           <a:lstStyle/>
           <a:p>
             <a:pPr>
+              <a:defRPr sz="1800" b="1">
+                <a:solidFill>
+                  <a:srgbClr val="F8FAFC"/>
+                </a:solidFill>
+                <a:latin typeface="Malgun Gothic"/>
+              </a:defRPr>
+            </a:pPr>
+            <a:r>
+              <a:t>T03 품질 경고</a:t>
+            </a:r>
+          </a:p>
+          <a:p>
+            <a:pPr>
+              <a:spcBef>
+                <a:spcPts val="200"/>
+              </a:spcBef>
+              <a:defRPr sz="1250" b="1">
+                <a:solidFill>
+                  <a:srgbClr val="34D399"/>
+                </a:solidFill>
+                <a:latin typeface="Malgun Gothic"/>
+              </a:defRPr>
+            </a:pPr>
+            <a:r>
+              <a:t>✔ E2E PASS (HTTP 200)</a:t>
+            </a:r>
+          </a:p>
+          <a:p>
+            <a:pPr>
+              <a:spcBef>
+                <a:spcPts val="800"/>
+              </a:spcBef>
+              <a:defRPr sz="1100">
+                <a:solidFill>
+                  <a:srgbClr val="94A3B8"/>
+                </a:solidFill>
+                <a:latin typeface="Malgun Gothic"/>
+              </a:defRPr>
+            </a:pPr>
+            <a:r>
+              <a:t>최종 판정</a:t>
+            </a:r>
+          </a:p>
+          <a:p>
+            <a:pPr>
               <a:defRPr sz="1500" b="1">
                 <a:solidFill>
+                  <a:srgbClr val="FBBF24"/>
+                </a:solidFill>
+                <a:latin typeface="Malgun Gothic"/>
+              </a:defRPr>
+            </a:pPr>
+            <a:r>
+              <a:t>최종 REINSPECT</a:t>
+            </a:r>
+          </a:p>
+          <a:p>
+            <a:pPr>
+              <a:defRPr sz="1000">
+                <a:solidFill>
+                  <a:srgbClr val="CBD5E1"/>
+                </a:solidFill>
+                <a:latin typeface="Malgun Gothic"/>
+              </a:defRPr>
+            </a:pPr>
+            <a:r>
+              <a:t>(조도 저하 81.24 ➔ 재검)</a:t>
+            </a:r>
+          </a:p>
+          <a:p>
+            <a:pPr>
+              <a:spcBef>
+                <a:spcPts val="800"/>
+              </a:spcBef>
+              <a:defRPr sz="1100">
+                <a:solidFill>
+                  <a:srgbClr val="94A3B8"/>
+                </a:solidFill>
+                <a:latin typeface="Malgun Gothic"/>
+              </a:defRPr>
+            </a:pPr>
+            <a:r>
+              <a:t>전체 E2E 소요시간</a:t>
+            </a:r>
+          </a:p>
+          <a:p>
+            <a:pPr>
+              <a:defRPr sz="1700" b="1">
+                <a:solidFill>
+                  <a:srgbClr val="4CD7F6"/>
+                </a:solidFill>
+                <a:latin typeface="Malgun Gothic"/>
+              </a:defRPr>
+            </a:pPr>
+            <a:r>
+              <a:t>24.60초</a:t>
+            </a:r>
+          </a:p>
+          <a:p>
+            <a:pPr>
+              <a:spcBef>
+                <a:spcPts val="800"/>
+              </a:spcBef>
+              <a:defRPr sz="1100">
+                <a:solidFill>
+                  <a:srgbClr val="94A3B8"/>
+                </a:solidFill>
+                <a:latin typeface="Malgun Gothic"/>
+              </a:defRPr>
+            </a:pPr>
+            <a:r>
+              <a:t>검증 Fact (근거)</a:t>
+            </a:r>
+          </a:p>
+          <a:p>
+            <a:pPr>
+              <a:defRPr sz="1350" b="1">
+                <a:solidFill>
                   <a:srgbClr val="34D399"/>
                 </a:solidFill>
                 <a:latin typeface="Malgun Gothic"/>
               </a:defRPr>
             </a:pPr>
             <a:r>
-              <a:t>T03 조도 저하 시나리오: 실서버 E2E 성공 (PASS)</a:t>
-            </a:r>
-          </a:p>
-          <a:p>
-            <a:pPr>
-              <a:spcBef>
-                <a:spcPts val="400"/>
-              </a:spcBef>
+              <a:t>Fact 12개 (100% 검증 통과)</a:t>
+            </a:r>
+          </a:p>
+          <a:p>
+            <a:pPr>
+              <a:spcBef>
+                <a:spcPts val="800"/>
+              </a:spcBef>
+              <a:defRPr sz="950">
+                <a:solidFill>
+                  <a:srgbClr val="CBD5E1"/>
+                </a:solidFill>
+                <a:latin typeface="Malgun Gothic"/>
+              </a:defRPr>
+            </a:pPr>
+            <a:r>
+              <a:t>• Rule 2 (IMAGE_QUALITY_WARN)</a:t>
+            </a:r>
+            <a:br/>
+            <a:r>
+              <a:t>• 도구 2개 / 9,873 토큰</a:t>
+            </a:r>
+            <a:br/>
+            <a:r>
+              <a:t>• 권고: 조명 점검 &amp; 안전 재검사</a:t>
+            </a:r>
+            <a:br/>
+            <a:r>
+              <a:t>• 검사 ID: INSP-001398</a:t>
+            </a:r>
+          </a:p>
+        </p:txBody>
+      </p:sp>
+      <p:sp>
+        <p:nvSpPr>
+          <p:cNvPr id="9" name="Rounded Rectangle 8"/>
+          <p:cNvSpPr/>
+          <p:nvPr/>
+        </p:nvSpPr>
+        <p:spPr>
+          <a:xfrm>
+            <a:off x="6206947" y="1261872"/>
+            <a:ext cx="2514600" cy="4096512"/>
+          </a:xfrm>
+          <a:prstGeom prst="roundRect">
+            <a:avLst/>
+          </a:prstGeom>
+          <a:solidFill>
+            <a:srgbClr val="161E2E"/>
+          </a:solidFill>
+          <a:ln w="12700">
+            <a:solidFill>
+              <a:srgbClr val="34D399"/>
+            </a:solidFill>
+          </a:ln>
+        </p:spPr>
+        <p:style>
+          <a:lnRef idx="1">
+            <a:schemeClr val="accent1"/>
+          </a:lnRef>
+          <a:fillRef idx="3">
+            <a:schemeClr val="accent1"/>
+          </a:fillRef>
+          <a:effectRef idx="2">
+            <a:schemeClr val="accent1"/>
+          </a:effectRef>
+          <a:fontRef idx="minor">
+            <a:schemeClr val="lt1"/>
+          </a:fontRef>
+        </p:style>
+        <p:txBody>
+          <a:bodyPr rtlCol="0" anchor="ctr"/>
+          <a:lstStyle/>
+          <a:p>
+            <a:pPr algn="ctr"/>
+          </a:p>
+        </p:txBody>
+      </p:sp>
+      <p:sp>
+        <p:nvSpPr>
+          <p:cNvPr id="10" name="TextBox 9"/>
+          <p:cNvSpPr txBox="1"/>
+          <p:nvPr/>
+        </p:nvSpPr>
+        <p:spPr>
+          <a:xfrm>
+            <a:off x="6316675" y="1316736"/>
+            <a:ext cx="2295144" cy="3977639"/>
+          </a:xfrm>
+          <a:prstGeom prst="rect">
+            <a:avLst/>
+          </a:prstGeom>
+          <a:noFill/>
+        </p:spPr>
+        <p:txBody>
+          <a:bodyPr wrap="square">
+            <a:spAutoFit/>
+          </a:bodyPr>
+          <a:lstStyle/>
+          <a:p>
+            <a:pPr>
+              <a:defRPr sz="1800" b="1">
+                <a:solidFill>
+                  <a:srgbClr val="F8FAFC"/>
+                </a:solidFill>
+                <a:latin typeface="Malgun Gothic"/>
+              </a:defRPr>
+            </a:pPr>
+            <a:r>
+              <a:t>T05 로드 실패</a:t>
+            </a:r>
+          </a:p>
+          <a:p>
+            <a:pPr>
+              <a:spcBef>
+                <a:spcPts val="200"/>
+              </a:spcBef>
+              <a:defRPr sz="1250" b="1">
+                <a:solidFill>
+                  <a:srgbClr val="34D399"/>
+                </a:solidFill>
+                <a:latin typeface="Malgun Gothic"/>
+              </a:defRPr>
+            </a:pPr>
+            <a:r>
+              <a:t>✔ E2E PASS (HTTP 200)</a:t>
+            </a:r>
+          </a:p>
+          <a:p>
+            <a:pPr>
+              <a:spcBef>
+                <a:spcPts val="800"/>
+              </a:spcBef>
+              <a:defRPr sz="1100">
+                <a:solidFill>
+                  <a:srgbClr val="94A3B8"/>
+                </a:solidFill>
+                <a:latin typeface="Malgun Gothic"/>
+              </a:defRPr>
+            </a:pPr>
+            <a:r>
+              <a:t>최종 판정</a:t>
+            </a:r>
+          </a:p>
+          <a:p>
+            <a:pPr>
+              <a:defRPr sz="1500" b="1">
+                <a:solidFill>
+                  <a:srgbClr val="F87171"/>
+                </a:solidFill>
+                <a:latin typeface="Malgun Gothic"/>
+              </a:defRPr>
+            </a:pPr>
+            <a:r>
+              <a:t>최종 ERROR</a:t>
+            </a:r>
+          </a:p>
+          <a:p>
+            <a:pPr>
               <a:defRPr sz="1000">
                 <a:solidFill>
                   <a:srgbClr val="CBD5E1"/>
@@ -3763,151 +4046,403 @@
               </a:defRPr>
             </a:pPr>
             <a:r>
-              <a:t>• 검사 식별자: INSP-001398 (조도 저하 주입 검사)</a:t>
-            </a:r>
-          </a:p>
-          <a:p>
-            <a:pPr>
-              <a:spcBef>
-                <a:spcPts val="400"/>
-              </a:spcBef>
+              <a:t>(영상 손상 ➔ 조기 종료)</a:t>
+            </a:r>
+          </a:p>
+          <a:p>
+            <a:pPr>
+              <a:spcBef>
+                <a:spcPts val="800"/>
+              </a:spcBef>
+              <a:defRPr sz="1100">
+                <a:solidFill>
+                  <a:srgbClr val="94A3B8"/>
+                </a:solidFill>
+                <a:latin typeface="Malgun Gothic"/>
+              </a:defRPr>
+            </a:pPr>
+            <a:r>
+              <a:t>전체 E2E 소요시간</a:t>
+            </a:r>
+          </a:p>
+          <a:p>
+            <a:pPr>
+              <a:defRPr sz="1700" b="1">
+                <a:solidFill>
+                  <a:srgbClr val="4CD7F6"/>
+                </a:solidFill>
+                <a:latin typeface="Malgun Gothic"/>
+              </a:defRPr>
+            </a:pPr>
+            <a:r>
+              <a:t>16.33초</a:t>
+            </a:r>
+          </a:p>
+          <a:p>
+            <a:pPr>
+              <a:spcBef>
+                <a:spcPts val="800"/>
+              </a:spcBef>
+              <a:defRPr sz="1100">
+                <a:solidFill>
+                  <a:srgbClr val="94A3B8"/>
+                </a:solidFill>
+                <a:latin typeface="Malgun Gothic"/>
+              </a:defRPr>
+            </a:pPr>
+            <a:r>
+              <a:t>검증 Fact (근거)</a:t>
+            </a:r>
+          </a:p>
+          <a:p>
+            <a:pPr>
+              <a:defRPr sz="1350" b="1">
+                <a:solidFill>
+                  <a:srgbClr val="34D399"/>
+                </a:solidFill>
+                <a:latin typeface="Malgun Gothic"/>
+              </a:defRPr>
+            </a:pPr>
+            <a:r>
+              <a:t>Fact 17개 (100% 검증 통과)</a:t>
+            </a:r>
+          </a:p>
+          <a:p>
+            <a:pPr>
+              <a:spcBef>
+                <a:spcPts val="800"/>
+              </a:spcBef>
+              <a:defRPr sz="950">
+                <a:solidFill>
+                  <a:srgbClr val="CBD5E1"/>
+                </a:solidFill>
+                <a:latin typeface="Malgun Gothic"/>
+              </a:defRPr>
+            </a:pPr>
+            <a:r>
+              <a:t>• Rule 1 (INSPECTION_FAILED)</a:t>
+            </a:r>
+            <a:br/>
+            <a:r>
+              <a:t>• 도구 2개 / 11,426 토큰</a:t>
+            </a:r>
+            <a:br/>
+            <a:r>
+              <a:t>• 권고: 파일/카메라 점검 (오추론 방지)</a:t>
+            </a:r>
+            <a:br/>
+            <a:r>
+              <a:t>• 검사 ID: INSP-001405</a:t>
+            </a:r>
+          </a:p>
+        </p:txBody>
+      </p:sp>
+      <p:sp>
+        <p:nvSpPr>
+          <p:cNvPr id="11" name="Rounded Rectangle 10"/>
+          <p:cNvSpPr/>
+          <p:nvPr/>
+        </p:nvSpPr>
+        <p:spPr>
+          <a:xfrm>
+            <a:off x="8944660" y="1261872"/>
+            <a:ext cx="2514600" cy="4096512"/>
+          </a:xfrm>
+          <a:prstGeom prst="roundRect">
+            <a:avLst/>
+          </a:prstGeom>
+          <a:solidFill>
+            <a:srgbClr val="161E2E"/>
+          </a:solidFill>
+          <a:ln w="12700">
+            <a:solidFill>
+              <a:srgbClr val="34D399"/>
+            </a:solidFill>
+          </a:ln>
+        </p:spPr>
+        <p:style>
+          <a:lnRef idx="1">
+            <a:schemeClr val="accent1"/>
+          </a:lnRef>
+          <a:fillRef idx="3">
+            <a:schemeClr val="accent1"/>
+          </a:fillRef>
+          <a:effectRef idx="2">
+            <a:schemeClr val="accent1"/>
+          </a:effectRef>
+          <a:fontRef idx="minor">
+            <a:schemeClr val="lt1"/>
+          </a:fontRef>
+        </p:style>
+        <p:txBody>
+          <a:bodyPr rtlCol="0" anchor="ctr"/>
+          <a:lstStyle/>
+          <a:p>
+            <a:pPr algn="ctr"/>
+          </a:p>
+        </p:txBody>
+      </p:sp>
+      <p:sp>
+        <p:nvSpPr>
+          <p:cNvPr id="12" name="TextBox 11"/>
+          <p:cNvSpPr txBox="1"/>
+          <p:nvPr/>
+        </p:nvSpPr>
+        <p:spPr>
+          <a:xfrm>
+            <a:off x="9054388" y="1316736"/>
+            <a:ext cx="2295144" cy="3977639"/>
+          </a:xfrm>
+          <a:prstGeom prst="rect">
+            <a:avLst/>
+          </a:prstGeom>
+          <a:noFill/>
+        </p:spPr>
+        <p:txBody>
+          <a:bodyPr wrap="square">
+            <a:spAutoFit/>
+          </a:bodyPr>
+          <a:lstStyle/>
+          <a:p>
+            <a:pPr>
+              <a:defRPr sz="1800" b="1">
+                <a:solidFill>
+                  <a:srgbClr val="F8FAFC"/>
+                </a:solidFill>
+                <a:latin typeface="Malgun Gothic"/>
+              </a:defRPr>
+            </a:pPr>
+            <a:r>
+              <a:t>T06 저장 OK</a:t>
+            </a:r>
+          </a:p>
+          <a:p>
+            <a:pPr>
+              <a:spcBef>
+                <a:spcPts val="200"/>
+              </a:spcBef>
+              <a:defRPr sz="1250" b="1">
+                <a:solidFill>
+                  <a:srgbClr val="34D399"/>
+                </a:solidFill>
+                <a:latin typeface="Malgun Gothic"/>
+              </a:defRPr>
+            </a:pPr>
+            <a:r>
+              <a:t>✔ E2E PASS (HTTP 200)</a:t>
+            </a:r>
+          </a:p>
+          <a:p>
+            <a:pPr>
+              <a:spcBef>
+                <a:spcPts val="800"/>
+              </a:spcBef>
+              <a:defRPr sz="1100">
+                <a:solidFill>
+                  <a:srgbClr val="94A3B8"/>
+                </a:solidFill>
+                <a:latin typeface="Malgun Gothic"/>
+              </a:defRPr>
+            </a:pPr>
+            <a:r>
+              <a:t>최종 판정</a:t>
+            </a:r>
+          </a:p>
+          <a:p>
+            <a:pPr>
+              <a:defRPr sz="1500" b="1">
+                <a:solidFill>
+                  <a:srgbClr val="34D399"/>
+                </a:solidFill>
+                <a:latin typeface="Malgun Gothic"/>
+              </a:defRPr>
+            </a:pPr>
+            <a:r>
+              <a:t>최종 OK (불변)</a:t>
+            </a:r>
+          </a:p>
+          <a:p>
+            <a:pPr>
               <a:defRPr sz="1000">
                 <a:solidFill>
+                  <a:srgbClr val="CBD5E1"/>
+                </a:solidFill>
+                <a:latin typeface="Malgun Gothic"/>
+              </a:defRPr>
+            </a:pPr>
+            <a:r>
+              <a:t>(서버 원본 판정 보존)</a:t>
+            </a:r>
+          </a:p>
+          <a:p>
+            <a:pPr>
+              <a:spcBef>
+                <a:spcPts val="800"/>
+              </a:spcBef>
+              <a:defRPr sz="1100">
+                <a:solidFill>
+                  <a:srgbClr val="94A3B8"/>
+                </a:solidFill>
+                <a:latin typeface="Malgun Gothic"/>
+              </a:defRPr>
+            </a:pPr>
+            <a:r>
+              <a:t>전체 E2E 소요시간</a:t>
+            </a:r>
+          </a:p>
+          <a:p>
+            <a:pPr>
+              <a:defRPr sz="1700" b="1">
+                <a:solidFill>
+                  <a:srgbClr val="4CD7F6"/>
+                </a:solidFill>
+                <a:latin typeface="Malgun Gothic"/>
+              </a:defRPr>
+            </a:pPr>
+            <a:r>
+              <a:t>26.37초</a:t>
+            </a:r>
+          </a:p>
+          <a:p>
+            <a:pPr>
+              <a:spcBef>
+                <a:spcPts val="800"/>
+              </a:spcBef>
+              <a:defRPr sz="1100">
+                <a:solidFill>
+                  <a:srgbClr val="94A3B8"/>
+                </a:solidFill>
+                <a:latin typeface="Malgun Gothic"/>
+              </a:defRPr>
+            </a:pPr>
+            <a:r>
+              <a:t>검증 Fact (근거)</a:t>
+            </a:r>
+          </a:p>
+          <a:p>
+            <a:pPr>
+              <a:defRPr sz="1350" b="1">
+                <a:solidFill>
+                  <a:srgbClr val="34D399"/>
+                </a:solidFill>
+                <a:latin typeface="Malgun Gothic"/>
+              </a:defRPr>
+            </a:pPr>
+            <a:r>
+              <a:t>Fact 6개 (100% 검증 통과)</a:t>
+            </a:r>
+          </a:p>
+          <a:p>
+            <a:pPr>
+              <a:spcBef>
+                <a:spcPts val="800"/>
+              </a:spcBef>
+              <a:defRPr sz="950">
+                <a:solidFill>
+                  <a:srgbClr val="CBD5E1"/>
+                </a:solidFill>
+                <a:latin typeface="Malgun Gothic"/>
+              </a:defRPr>
+            </a:pPr>
+            <a:r>
+              <a:t>• 서버 원본 판정 가드레일</a:t>
+            </a:r>
+            <a:br/>
+            <a:r>
+              <a:t>• 도구 1개 / 7,202 토큰</a:t>
+            </a:r>
+            <a:br/>
+            <a:r>
+              <a:t>• 권고: 정답 미노출 &amp; 판정 보존</a:t>
+            </a:r>
+            <a:br/>
+            <a:r>
+              <a:t>• 검사 ID: INSP-001406</a:t>
+            </a:r>
+          </a:p>
+        </p:txBody>
+      </p:sp>
+      <p:sp>
+        <p:nvSpPr>
+          <p:cNvPr id="13" name="Rounded Rectangle 12"/>
+          <p:cNvSpPr/>
+          <p:nvPr/>
+        </p:nvSpPr>
+        <p:spPr>
+          <a:xfrm>
+            <a:off x="731520" y="5440680"/>
+            <a:ext cx="10728655" cy="777240"/>
+          </a:xfrm>
+          <a:prstGeom prst="roundRect">
+            <a:avLst/>
+          </a:prstGeom>
+          <a:solidFill>
+            <a:srgbClr val="101726"/>
+          </a:solidFill>
+          <a:ln w="12700">
+            <a:solidFill>
+              <a:srgbClr val="4CD7F6"/>
+            </a:solidFill>
+          </a:ln>
+        </p:spPr>
+        <p:style>
+          <a:lnRef idx="1">
+            <a:schemeClr val="accent1"/>
+          </a:lnRef>
+          <a:fillRef idx="3">
+            <a:schemeClr val="accent1"/>
+          </a:fillRef>
+          <a:effectRef idx="2">
+            <a:schemeClr val="accent1"/>
+          </a:effectRef>
+          <a:fontRef idx="minor">
+            <a:schemeClr val="lt1"/>
+          </a:fontRef>
+        </p:style>
+        <p:txBody>
+          <a:bodyPr rtlCol="0" anchor="ctr"/>
+          <a:lstStyle/>
+          <a:p>
+            <a:pPr algn="ctr"/>
+          </a:p>
+        </p:txBody>
+      </p:sp>
+      <p:sp>
+        <p:nvSpPr>
+          <p:cNvPr id="14" name="TextBox 13"/>
+          <p:cNvSpPr txBox="1"/>
+          <p:nvPr/>
+        </p:nvSpPr>
+        <p:spPr>
+          <a:xfrm>
+            <a:off x="914400" y="5486400"/>
+            <a:ext cx="10332720" cy="685800"/>
+          </a:xfrm>
+          <a:prstGeom prst="rect">
+            <a:avLst/>
+          </a:prstGeom>
+          <a:noFill/>
+        </p:spPr>
+        <p:txBody>
+          <a:bodyPr wrap="square">
+            <a:spAutoFit/>
+          </a:bodyPr>
+          <a:lstStyle/>
+          <a:p>
+            <a:pPr algn="ctr">
+              <a:defRPr sz="1050" b="1">
+                <a:solidFill>
                   <a:srgbClr val="F8FAFC"/>
                 </a:solidFill>
                 <a:latin typeface="Malgun Gothic"/>
               </a:defRPr>
             </a:pPr>
             <a:r>
-              <a:t>• 판정 결과: 모델 OK  ➔  서버 최종 REINSPECT (Rule 2 발급)</a:t>
-            </a:r>
-          </a:p>
-          <a:p>
-            <a:pPr>
-              <a:spcBef>
-                <a:spcPts val="400"/>
-              </a:spcBef>
-              <a:defRPr sz="1000">
-                <a:solidFill>
-                  <a:srgbClr val="CBD5E1"/>
-                </a:solidFill>
-                <a:latin typeface="Malgun Gothic"/>
-              </a:defRPr>
-            </a:pPr>
-            <a:r>
-              <a:t>• FastAPI 응답: HTTP 200 OK  (analysis_status: COMPLETED, 회차 final30_1)</a:t>
-            </a:r>
-          </a:p>
-          <a:p>
-            <a:pPr>
-              <a:spcBef>
-                <a:spcPts val="400"/>
-              </a:spcBef>
-              <a:defRPr sz="1000">
-                <a:solidFill>
-                  <a:srgbClr val="CBD5E1"/>
-                </a:solidFill>
-                <a:latin typeface="Malgun Gothic"/>
-              </a:defRPr>
-            </a:pPr>
-            <a:r>
-              <a:t>• Gemini 통신: 3회 모두 HTTP 200 성공 (전체 소요: 24.600초)</a:t>
-            </a:r>
-          </a:p>
-          <a:p>
-            <a:pPr>
-              <a:spcBef>
-                <a:spcPts val="400"/>
-              </a:spcBef>
-              <a:defRPr sz="1000">
-                <a:solidFill>
-                  <a:srgbClr val="CBD5E1"/>
-                </a:solidFill>
-                <a:latin typeface="Malgun Gothic"/>
-              </a:defRPr>
-            </a:pPr>
-            <a:r>
-              <a:t>• 토큰 사용량: 총 9,873 토큰 (입력 5,576, 출력 345, Thinking 3,952)</a:t>
-            </a:r>
-          </a:p>
-          <a:p>
-            <a:pPr>
-              <a:spcBef>
-                <a:spcPts val="400"/>
-              </a:spcBef>
-              <a:defRPr sz="1000">
-                <a:solidFill>
-                  <a:srgbClr val="CBD5E1"/>
-                </a:solidFill>
-                <a:latin typeface="Malgun Gothic"/>
-              </a:defRPr>
-            </a:pPr>
-            <a:r>
-              <a:t>• 도구 순차 실행: 도구1(E0001 2.43s) ➔ 도구2(E0002 3.05s) 순차 실행</a:t>
-            </a:r>
-          </a:p>
-          <a:p>
-            <a:pPr>
-              <a:spcBef>
-                <a:spcPts val="400"/>
-              </a:spcBef>
-              <a:defRPr sz="1000">
-                <a:solidFill>
-                  <a:srgbClr val="F8FAFC"/>
-                </a:solidFill>
-                <a:latin typeface="Malgun Gothic"/>
-              </a:defRPr>
-            </a:pPr>
-            <a:r>
-              <a:t>• 최종 단순 JSON 생성: 18.967초 (HTTP 200, 30초 timeout 선택 적용)</a:t>
-            </a:r>
-          </a:p>
-          <a:p>
-            <a:pPr>
-              <a:spcBef>
-                <a:spcPts val="400"/>
-              </a:spcBef>
-              <a:defRPr sz="1000">
-                <a:solidFill>
-                  <a:srgbClr val="F8FAFC"/>
-                </a:solidFill>
-                <a:latin typeface="Malgun Gothic"/>
-              </a:defRPr>
-            </a:pPr>
-            <a:r>
-              <a:t>• 근거 검증: 관측 사실 12개 (F0001~F0012) 1:1 결정적 검증 100% 통과</a:t>
-            </a:r>
-          </a:p>
-          <a:p>
-            <a:pPr>
-              <a:spcBef>
-                <a:spcPts val="400"/>
-              </a:spcBef>
-              <a:defRPr sz="1000">
-                <a:solidFill>
-                  <a:srgbClr val="CBD5E1"/>
-                </a:solidFill>
-                <a:latin typeface="Malgun Gothic"/>
-              </a:defRPr>
-            </a:pPr>
-            <a:r>
-              <a:t>• 판정 불변 보존: Gemini가 서버의 REINSPECT 판정을 번복하지 않고 보존</a:t>
-            </a:r>
-          </a:p>
-          <a:p>
-            <a:pPr>
-              <a:spcBef>
-                <a:spcPts val="500"/>
-              </a:spcBef>
-              <a:defRPr sz="850">
-                <a:solidFill>
-                  <a:srgbClr val="94A3B8"/>
-                </a:solidFill>
-                <a:latin typeface="Malgun Gothic"/>
-              </a:defRPr>
-            </a:pPr>
-            <a:r>
-              <a:t>*(최종 JSON에 한해 30s timeout을 선택 적용하여 성공. 과거 504 원인은 UNKNOWN이며 단일 성공으로 향후 안정성을 보장하지 않음)</a:t>
+              <a:t>💡 실서버 E2E 성과: 4대 대표 시나리오 전원 HTTP 200 / 관측 사실 100% 통과 달성</a:t>
+            </a:r>
+            <a:br/>
+            <a:r>
+              <a:t>*(T06: 30초 timeout 설정 회차 성공이나 504 직접 해결은 미확정이며, 원본 ASGI 본문 미보관으로 재구성 코드 기반 사후 검토 한계 명시)</a:t>
             </a:r>
           </a:p>
         </p:txBody>
@@ -4349,7 +4884,7 @@
               </a:defRPr>
             </a:pPr>
             <a:r>
-              <a:t>   기록된 모델 판정과 종합 판정은 OK입니다. 실제 무결점 제품을 보증하지는 않습니다.</a:t>
+              <a:t>   기록된 판정은 OK입니다. 실제 무결점 제품을 보증하지는 않습니다. (CONTINUE_MONITORING)</a:t>
             </a:r>
           </a:p>
           <a:p>
@@ -4365,7 +4900,7 @@
               </a:defRPr>
             </a:pPr>
             <a:r>
-              <a:t>✔ T01 권장 조치</a:t>
+              <a:t>✔ T03 종합 요약</a:t>
             </a:r>
           </a:p>
           <a:p>
@@ -4378,7 +4913,7 @@
               </a:defRPr>
             </a:pPr>
             <a:r>
-              <a:t>   check_code: CONTINUE_MONITORING (근거 참조: F0003 앵커링)</a:t>
+              <a:t>   종합 판정은 REINSPECT입니다. 제품 불량 확정과 구분하여 재검 필요. (조명점검/재검 권고)</a:t>
             </a:r>
           </a:p>
           <a:p>
@@ -4394,7 +4929,7 @@
               </a:defRPr>
             </a:pPr>
             <a:r>
-              <a:t>✔ T03 종합 요약</a:t>
+              <a:t>✔ T05 로드 실패</a:t>
             </a:r>
           </a:p>
           <a:p>
@@ -4407,7 +4942,7 @@
               </a:defRPr>
             </a:pPr>
             <a:r>
-              <a:t>   기록된 종합 판정은 REINSPECT입니다. 제품 불량 확정과 구분하여 재검사가 필요합니다.</a:t>
+              <a:t>   영상 로드 실패 시 원천 사실 17개 기반 조기 종료, 모델 체크포인트 장애 오추론 방지</a:t>
             </a:r>
           </a:p>
           <a:p>
@@ -4423,7 +4958,7 @@
               </a:defRPr>
             </a:pPr>
             <a:r>
-              <a:t>✔ T03 권장 조치</a:t>
+              <a:t>✔ T06 판정 보존</a:t>
             </a:r>
           </a:p>
           <a:p>
@@ -4436,7 +4971,7 @@
               </a:defRPr>
             </a:pPr>
             <a:r>
-              <a:t>   LIGHTING_EXPOSURE_CHECK (F0004, F0007 참조), MANUAL_REINSPECTION (F0003 참조)</a:t>
+              <a:t>   외부 평가상 미탐 사례라도 정답 미제공 상태에서 서버 원본 final_result=OK 불변 유지</a:t>
             </a:r>
           </a:p>
           <a:p>
@@ -4465,7 +5000,7 @@
               </a:defRPr>
             </a:pPr>
             <a:r>
-              <a:t>   4대 limitations 필수 명시 (물리적 원인 불명, 모델 무결점 비보증, 기준치 미기록 등)</a:t>
+              <a:t>   limitations 필수 명시 (물리적 원인 불명, 모델 무결점 비보증, 설비 미제어 등)</a:t>
             </a:r>
           </a:p>
           <a:p>
@@ -4494,7 +5029,7 @@
               </a:defRPr>
             </a:pPr>
             <a:r>
-              <a:t>   발표 현장 네트워크 장애 및 과금 방지를 위해 사전 실서버 검증 데이터를 재생하는 독립 데모 사용</a:t>
+              <a:t>   현장 네트워크 장애/과금 방지를 위해 사전 실서버 검증 데이터를 재생하는 독립 데모 사용</a:t>
             </a:r>
           </a:p>
         </p:txBody>
@@ -4642,8 +5177,8 @@
         </p:nvSpPr>
         <p:spPr>
           <a:xfrm>
-            <a:off x="731520" y="1280160"/>
-            <a:ext cx="3383280" cy="4846320"/>
+            <a:off x="731520" y="1261872"/>
+            <a:ext cx="3383280" cy="4864608"/>
           </a:xfrm>
           <a:prstGeom prst="roundRect">
             <a:avLst/>
@@ -4687,8 +5222,8 @@
         </p:nvSpPr>
         <p:spPr>
           <a:xfrm>
-            <a:off x="896112" y="1508760"/>
-            <a:ext cx="3054096" cy="4389120"/>
+            <a:off x="877824" y="1371600"/>
+            <a:ext cx="3090672" cy="4663440"/>
           </a:xfrm>
           <a:prstGeom prst="rect">
             <a:avLst/>
@@ -4702,7 +5237,7 @@
           <a:lstStyle/>
           <a:p>
             <a:pPr>
-              <a:defRPr sz="1350" b="1">
+              <a:defRPr sz="1400" b="1">
                 <a:solidFill>
                   <a:srgbClr val="34D399"/>
                 </a:solidFill>
@@ -4710,7 +5245,7 @@
               </a:defRPr>
             </a:pPr>
             <a:r>
-              <a:t>1. 실제 Gemini E2E PASS</a:t>
+              <a:t>1. Day4 Agent PoC 완료 [공식 완료]</a:t>
             </a:r>
           </a:p>
           <a:p>
@@ -4718,7 +5253,39 @@
               <a:spcBef>
                 <a:spcPts val="500"/>
               </a:spcBef>
-              <a:defRPr sz="1000">
+              <a:defRPr sz="1100" b="1">
+                <a:solidFill>
+                  <a:srgbClr val="F8FAFC"/>
+                </a:solidFill>
+                <a:latin typeface="Malgun Gothic"/>
+              </a:defRPr>
+            </a:pPr>
+            <a:r>
+              <a:t>• 전체 pytest 1089 PASS / 4 SKIP (경고 2건)</a:t>
+            </a:r>
+          </a:p>
+          <a:p>
+            <a:pPr>
+              <a:spcBef>
+                <a:spcPts val="500"/>
+              </a:spcBef>
+              <a:defRPr sz="1100" b="1">
+                <a:solidFill>
+                  <a:srgbClr val="34D399"/>
+                </a:solidFill>
+                <a:latin typeface="Malgun Gothic"/>
+              </a:defRPr>
+            </a:pPr>
+            <a:r>
+              <a:t>• 4대 시나리오 실제 Gemini E2E 전원 성공</a:t>
+            </a:r>
+          </a:p>
+          <a:p>
+            <a:pPr>
+              <a:spcBef>
+                <a:spcPts val="200"/>
+              </a:spcBef>
+              <a:defRPr sz="1000" b="0">
                 <a:solidFill>
                   <a:srgbClr val="CBD5E1"/>
                 </a:solidFill>
@@ -4726,15 +5293,15 @@
               </a:defRPr>
             </a:pPr>
             <a:r>
-              <a:t>• FastAPI 백엔드 &amp; 고유 ID 발급</a:t>
-            </a:r>
-          </a:p>
-          <a:p>
-            <a:pPr>
-              <a:spcBef>
-                <a:spcPts val="500"/>
-              </a:spcBef>
-              <a:defRPr sz="1000">
+              <a:t>   - T01(13.58s) · T03(24.60s)</a:t>
+            </a:r>
+          </a:p>
+          <a:p>
+            <a:pPr>
+              <a:spcBef>
+                <a:spcPts val="200"/>
+              </a:spcBef>
+              <a:defRPr sz="1000" b="0">
                 <a:solidFill>
                   <a:srgbClr val="CBD5E1"/>
                 </a:solidFill>
@@ -4742,79 +5309,47 @@
               </a:defRPr>
             </a:pPr>
             <a:r>
-              <a:t>• PatchCore CPU 추론 엔진 (42.53ms)</a:t>
-            </a:r>
-          </a:p>
-          <a:p>
-            <a:pPr>
-              <a:spcBef>
-                <a:spcPts val="500"/>
-              </a:spcBef>
-              <a:defRPr sz="1000">
-                <a:solidFill>
-                  <a:srgbClr val="CBD5E1"/>
-                </a:solidFill>
-                <a:latin typeface="Malgun Gothic"/>
-              </a:defRPr>
-            </a:pPr>
-            <a:r>
-              <a:t>• 규칙 기반 종합 판정 (REINSPECT 분리)</a:t>
-            </a:r>
-          </a:p>
-          <a:p>
-            <a:pPr>
-              <a:spcBef>
-                <a:spcPts val="500"/>
-              </a:spcBef>
-              <a:defRPr sz="1000">
-                <a:solidFill>
-                  <a:srgbClr val="CBD5E1"/>
-                </a:solidFill>
-                <a:latin typeface="Malgun Gothic"/>
-              </a:defRPr>
-            </a:pPr>
-            <a:r>
-              <a:t>• Gemini 4대 조회 도구 바인딩</a:t>
-            </a:r>
-          </a:p>
-          <a:p>
-            <a:pPr>
-              <a:spcBef>
-                <a:spcPts val="500"/>
-              </a:spcBef>
-              <a:defRPr sz="1000">
-                <a:solidFill>
-                  <a:srgbClr val="CBD5E1"/>
-                </a:solidFill>
-                <a:latin typeface="Malgun Gothic"/>
-              </a:defRPr>
-            </a:pPr>
-            <a:r>
-              <a:t>• 결정적 근거 검증 (Evidence/Pointer)</a:t>
-            </a:r>
-          </a:p>
-          <a:p>
-            <a:pPr>
-              <a:spcBef>
-                <a:spcPts val="500"/>
-              </a:spcBef>
-              <a:defRPr sz="1000">
-                <a:solidFill>
-                  <a:srgbClr val="CBD5E1"/>
-                </a:solidFill>
-                <a:latin typeface="Malgun Gothic"/>
-              </a:defRPr>
-            </a:pPr>
-            <a:r>
-              <a:t>• 단순 JSON 스키마 호환 구조</a:t>
-            </a:r>
-          </a:p>
-          <a:p>
-            <a:pPr>
-              <a:spcBef>
-                <a:spcPts val="500"/>
-              </a:spcBef>
-              <a:defRPr sz="1000">
+              <a:t>   - T05(16.33s) · T06(26.37s)</a:t>
+            </a:r>
+          </a:p>
+          <a:p>
+            <a:pPr>
+              <a:spcBef>
+                <a:spcPts val="200"/>
+              </a:spcBef>
+              <a:defRPr sz="1000" b="0">
+                <a:solidFill>
+                  <a:srgbClr val="4CD7F6"/>
+                </a:solidFill>
+                <a:latin typeface="Malgun Gothic"/>
+              </a:defRPr>
+            </a:pPr>
+            <a:r>
+              <a:t>   - Gemini 4대 조회 도구 바인딩 &amp; 단순 JSON</a:t>
+            </a:r>
+          </a:p>
+          <a:p>
+            <a:pPr>
+              <a:spcBef>
+                <a:spcPts val="200"/>
+              </a:spcBef>
+              <a:defRPr sz="1000" b="0">
+                <a:solidFill>
+                  <a:srgbClr val="4CD7F6"/>
+                </a:solidFill>
+                <a:latin typeface="Malgun Gothic"/>
+              </a:defRPr>
+            </a:pPr>
+            <a:r>
+              <a:t>   - 결정적 근거 검증 (Evidence / JSON Pointer)</a:t>
+            </a:r>
+          </a:p>
+          <a:p>
+            <a:pPr>
+              <a:spcBef>
+                <a:spcPts val="200"/>
+              </a:spcBef>
+              <a:defRPr sz="1000" b="0">
                 <a:solidFill>
                   <a:srgbClr val="F8FAFC"/>
                 </a:solidFill>
@@ -4822,23 +5357,7 @@
               </a:defRPr>
             </a:pPr>
             <a:r>
-              <a:t>• T01 정상 실서버 E2E (PASS, 13.578s)</a:t>
-            </a:r>
-          </a:p>
-          <a:p>
-            <a:pPr>
-              <a:spcBef>
-                <a:spcPts val="500"/>
-              </a:spcBef>
-              <a:defRPr sz="1000">
-                <a:solidFill>
-                  <a:srgbClr val="F8FAFC"/>
-                </a:solidFill>
-                <a:latin typeface="Malgun Gothic"/>
-              </a:defRPr>
-            </a:pPr>
-            <a:r>
-              <a:t>• T03 경고 실서버 E2E (PASS, 24.600s)</a:t>
+              <a:t>   - 서버 최종 판정(final_result) 불변 보호</a:t>
             </a:r>
           </a:p>
         </p:txBody>
@@ -4851,8 +5370,8 @@
         </p:nvSpPr>
         <p:spPr>
           <a:xfrm>
-            <a:off x="4389120" y="1280160"/>
-            <a:ext cx="3383280" cy="4846320"/>
+            <a:off x="4389120" y="1261872"/>
+            <a:ext cx="3383280" cy="4864608"/>
           </a:xfrm>
           <a:prstGeom prst="roundRect">
             <a:avLst/>
@@ -4896,8 +5415,8 @@
         </p:nvSpPr>
         <p:spPr>
           <a:xfrm>
-            <a:off x="4553712" y="1508760"/>
-            <a:ext cx="3054096" cy="4389120"/>
+            <a:off x="4535424" y="1371600"/>
+            <a:ext cx="3090672" cy="4663440"/>
           </a:xfrm>
           <a:prstGeom prst="rect">
             <a:avLst/>
@@ -4911,7 +5430,7 @@
           <a:lstStyle/>
           <a:p>
             <a:pPr>
-              <a:defRPr sz="1350" b="1">
+              <a:defRPr sz="1400" b="1">
                 <a:solidFill>
                   <a:srgbClr val="4CD7F6"/>
                 </a:solidFill>
@@ -4919,7 +5438,7 @@
               </a:defRPr>
             </a:pPr>
             <a:r>
-              <a:t>2. 구현 및 오프라인 검증 PASS</a:t>
+              <a:t>2. Day5 반례 검증 &amp; 영상 [진행 중]</a:t>
             </a:r>
           </a:p>
           <a:p>
@@ -4927,15 +5446,31 @@
               <a:spcBef>
                 <a:spcPts val="500"/>
               </a:spcBef>
-              <a:defRPr sz="1000">
-                <a:solidFill>
-                  <a:srgbClr val="F8FAFC"/>
-                </a:solidFill>
-                <a:latin typeface="Malgun Gothic"/>
-              </a:defRPr>
-            </a:pPr>
-            <a:r>
-              <a:t>• 전체 pytest 984개 PASS (경고 3건)</a:t>
+              <a:defRPr sz="1100" b="1">
+                <a:solidFill>
+                  <a:srgbClr val="34D399"/>
+                </a:solidFill>
+                <a:latin typeface="Malgun Gothic"/>
+              </a:defRPr>
+            </a:pPr>
+            <a:r>
+              <a:t>• [Step 1] Agent 정책 감사: COMPLETE</a:t>
+            </a:r>
+          </a:p>
+          <a:p>
+            <a:pPr>
+              <a:spcBef>
+                <a:spcPts val="200"/>
+              </a:spcBef>
+              <a:defRPr sz="1000" b="0">
+                <a:solidFill>
+                  <a:srgbClr val="CBD5E1"/>
+                </a:solidFill>
+                <a:latin typeface="Malgun Gothic"/>
+              </a:defRPr>
+            </a:pPr>
+            <a:r>
+              <a:t>   - T03 이력·T05 실패·T06 격리·무관 WARN 공백 식별</a:t>
             </a:r>
           </a:p>
           <a:p>
@@ -4943,7 +5478,55 @@
               <a:spcBef>
                 <a:spcPts val="500"/>
               </a:spcBef>
-              <a:defRPr sz="1000">
+              <a:defRPr sz="1100" b="1">
+                <a:solidFill>
+                  <a:srgbClr val="34D399"/>
+                </a:solidFill>
+                <a:latin typeface="Malgun Gothic"/>
+              </a:defRPr>
+            </a:pPr>
+            <a:r>
+              <a:t>• [Step 1-B] 반례 5종 Mock 평가: 36회 PASS</a:t>
+            </a:r>
+          </a:p>
+          <a:p>
+            <a:pPr>
+              <a:spcBef>
+                <a:spcPts val="200"/>
+              </a:spcBef>
+              <a:defRPr sz="1000" b="0">
+                <a:solidFill>
+                  <a:srgbClr val="94A3B8"/>
+                </a:solidFill>
+                <a:latin typeface="Malgun Gothic"/>
+              </a:defRPr>
+            </a:pPr>
+            <a:r>
+              <a:t>   - 오프라인 고정 계약 검증 통과 (PARTIAL)</a:t>
+            </a:r>
+          </a:p>
+          <a:p>
+            <a:pPr>
+              <a:spcBef>
+                <a:spcPts val="500"/>
+              </a:spcBef>
+              <a:defRPr sz="1100" b="1">
+                <a:solidFill>
+                  <a:srgbClr val="FBBF24"/>
+                </a:solidFill>
+                <a:latin typeface="Malgun Gothic"/>
+              </a:defRPr>
+            </a:pPr>
+            <a:r>
+              <a:t>• [개정 Day5] 영상 파이프라인 (예정)</a:t>
+            </a:r>
+          </a:p>
+          <a:p>
+            <a:pPr>
+              <a:spcBef>
+                <a:spcPts val="200"/>
+              </a:spcBef>
+              <a:defRPr sz="1000" b="0">
                 <a:solidFill>
                   <a:srgbClr val="CBD5E1"/>
                 </a:solidFill>
@@ -4951,15 +5534,15 @@
               </a:defRPr>
             </a:pPr>
             <a:r>
-              <a:t>• ERROR 필수 17개 원천 사실 정책 구현</a:t>
-            </a:r>
-          </a:p>
-          <a:p>
-            <a:pPr>
-              <a:spcBef>
-                <a:spcPts val="500"/>
-              </a:spcBef>
-              <a:defRPr sz="1000">
+              <a:t>   - VideoFileSource 동영상 프레임 수동 Grab</a:t>
+            </a:r>
+          </a:p>
+          <a:p>
+            <a:pPr>
+              <a:spcBef>
+                <a:spcPts val="200"/>
+              </a:spcBef>
+              <a:defRPr sz="1000" b="0">
                 <a:solidFill>
                   <a:srgbClr val="CBD5E1"/>
                 </a:solidFill>
@@ -4967,15 +5550,15 @@
               </a:defRPr>
             </a:pPr>
             <a:r>
-              <a:t>• T05 이미지 로드 실패 전용 조기 종료</a:t>
-            </a:r>
-          </a:p>
-          <a:p>
-            <a:pPr>
-              <a:spcBef>
-                <a:spcPts val="500"/>
-              </a:spcBef>
-              <a:defRPr sz="1000">
+              <a:t>   - 마우스 ROI 추출 ➔ 기존 PatchCore 추론 연결</a:t>
+            </a:r>
+          </a:p>
+          <a:p>
+            <a:pPr>
+              <a:spcBef>
+                <a:spcPts val="200"/>
+              </a:spcBef>
+              <a:defRPr sz="1000" b="0">
                 <a:solidFill>
                   <a:srgbClr val="CBD5E1"/>
                 </a:solidFill>
@@ -4983,71 +5566,7 @@
               </a:defRPr>
             </a:pPr>
             <a:r>
-              <a:t>•   - 필수 도구·로그 확보 후 최종 즉시 전환</a:t>
-            </a:r>
-          </a:p>
-          <a:p>
-            <a:pPr>
-              <a:spcBef>
-                <a:spcPts val="500"/>
-              </a:spcBef>
-              <a:defRPr sz="1000">
-                <a:solidFill>
-                  <a:srgbClr val="CBD5E1"/>
-                </a:solidFill>
-                <a:latin typeface="Malgun Gothic"/>
-              </a:defRPr>
-            </a:pPr>
-            <a:r>
-              <a:t>•   - Mock 조사 2회 + 최종 1회 통과</a:t>
-            </a:r>
-          </a:p>
-          <a:p>
-            <a:pPr>
-              <a:spcBef>
-                <a:spcPts val="500"/>
-              </a:spcBef>
-              <a:defRPr sz="1000">
-                <a:solidFill>
-                  <a:srgbClr val="CBD5E1"/>
-                </a:solidFill>
-                <a:latin typeface="Malgun Gothic"/>
-              </a:defRPr>
-            </a:pPr>
-            <a:r>
-              <a:t>• 계측기 WARNING 오분류 정정</a:t>
-            </a:r>
-          </a:p>
-          <a:p>
-            <a:pPr>
-              <a:spcBef>
-                <a:spcPts val="500"/>
-              </a:spcBef>
-              <a:defRPr sz="1000">
-                <a:solidFill>
-                  <a:srgbClr val="F87171"/>
-                </a:solidFill>
-                <a:latin typeface="Malgun Gothic"/>
-              </a:defRPr>
-            </a:pPr>
-            <a:r>
-              <a:t>•   - IMAGE_LOAD_FAILURE 정상 인식</a:t>
-            </a:r>
-          </a:p>
-          <a:p>
-            <a:pPr>
-              <a:spcBef>
-                <a:spcPts val="500"/>
-              </a:spcBef>
-              <a:defRPr sz="1000">
-                <a:solidFill>
-                  <a:srgbClr val="CBD5E1"/>
-                </a:solidFill>
-                <a:latin typeface="Malgun Gothic"/>
-              </a:defRPr>
-            </a:pPr>
-            <a:r>
-              <a:t>• T03 경고 조기 종료 오프라인 검증</a:t>
+              <a:t>   - data/inspection_logs.jsonl 분리 정리</a:t>
             </a:r>
           </a:p>
         </p:txBody>
@@ -5060,8 +5579,8 @@
         </p:nvSpPr>
         <p:spPr>
           <a:xfrm>
-            <a:off x="8046720" y="1280160"/>
-            <a:ext cx="3383280" cy="4846320"/>
+            <a:off x="8046720" y="1261872"/>
+            <a:ext cx="3383280" cy="4864608"/>
           </a:xfrm>
           <a:prstGeom prst="roundRect">
             <a:avLst/>
@@ -5105,8 +5624,8 @@
         </p:nvSpPr>
         <p:spPr>
           <a:xfrm>
-            <a:off x="8211312" y="1508760"/>
-            <a:ext cx="3054096" cy="4389120"/>
+            <a:off x="8193024" y="1371600"/>
+            <a:ext cx="3090672" cy="4663440"/>
           </a:xfrm>
           <a:prstGeom prst="rect">
             <a:avLst/>
@@ -5120,7 +5639,7 @@
           <a:lstStyle/>
           <a:p>
             <a:pPr>
-              <a:defRPr sz="1350" b="1">
+              <a:defRPr sz="1400" b="1">
                 <a:solidFill>
                   <a:srgbClr val="FBBF24"/>
                 </a:solidFill>
@@ -5128,7 +5647,7 @@
               </a:defRPr>
             </a:pPr>
             <a:r>
-              <a:t>3. 실제 E2E 미완료 &amp; 향후 과제</a:t>
+              <a:t>3. Day6~7 UI 및 클라우드 배포 [예정]</a:t>
             </a:r>
           </a:p>
           <a:p>
@@ -5136,15 +5655,63 @@
               <a:spcBef>
                 <a:spcPts val="500"/>
               </a:spcBef>
-              <a:defRPr sz="1000">
-                <a:solidFill>
-                  <a:srgbClr val="F87171"/>
-                </a:solidFill>
-                <a:latin typeface="Malgun Gothic"/>
-              </a:defRPr>
-            </a:pPr>
-            <a:r>
-              <a:t>• ※ T05 실제 E2E: 기존 1회 FAIL, 수정 후 재검증 대기</a:t>
+              <a:defRPr sz="1100" b="1">
+                <a:solidFill>
+                  <a:srgbClr val="FBBF24"/>
+                </a:solidFill>
+                <a:latin typeface="Malgun Gothic"/>
+              </a:defRPr>
+            </a:pPr>
+            <a:r>
+              <a:t>• [Day 6] React / TypeScript 웹 관제 (예정)</a:t>
+            </a:r>
+          </a:p>
+          <a:p>
+            <a:pPr>
+              <a:spcBef>
+                <a:spcPts val="200"/>
+              </a:spcBef>
+              <a:defRPr sz="1000" b="0">
+                <a:solidFill>
+                  <a:srgbClr val="CBD5E1"/>
+                </a:solidFill>
+                <a:latin typeface="Malgun Gothic"/>
+              </a:defRPr>
+            </a:pPr>
+            <a:r>
+              <a:t>   - 동영상 Live View &amp; Grab Image 뷰어</a:t>
+            </a:r>
+          </a:p>
+          <a:p>
+            <a:pPr>
+              <a:spcBef>
+                <a:spcPts val="200"/>
+              </a:spcBef>
+              <a:defRPr sz="1000" b="0">
+                <a:solidFill>
+                  <a:srgbClr val="CBD5E1"/>
+                </a:solidFill>
+                <a:latin typeface="Malgun Gothic"/>
+              </a:defRPr>
+            </a:pPr>
+            <a:r>
+              <a:t>   - 마우스 드래그 ROI &amp; 검사/로그 실시간 표출</a:t>
+            </a:r>
+          </a:p>
+          <a:p>
+            <a:pPr>
+              <a:spcBef>
+                <a:spcPts val="200"/>
+              </a:spcBef>
+              <a:defRPr sz="1000" b="0">
+                <a:solidFill>
+                  <a:srgbClr val="CBD5E1"/>
+                </a:solidFill>
+                <a:latin typeface="Malgun Gothic"/>
+              </a:defRPr>
+            </a:pPr>
+            <a:r>
+              <a:t>   - Gemini 사후 진단 보고서 표출 UI 패널</a:t>
             </a:r>
           </a:p>
           <a:p>
@@ -5152,23 +5719,23 @@
               <a:spcBef>
                 <a:spcPts val="500"/>
               </a:spcBef>
-              <a:defRPr sz="1000">
-                <a:solidFill>
-                  <a:srgbClr val="F87171"/>
-                </a:solidFill>
-                <a:latin typeface="Malgun Gothic"/>
-              </a:defRPr>
-            </a:pPr>
-            <a:r>
-              <a:t>• ※ T06 실제 E2E: NOT TESTED (미탐 사례 보존)</a:t>
-            </a:r>
-          </a:p>
-          <a:p>
-            <a:pPr>
-              <a:spcBef>
-                <a:spcPts val="500"/>
-              </a:spcBef>
-              <a:defRPr sz="1000">
+              <a:defRPr sz="1100" b="1">
+                <a:solidFill>
+                  <a:srgbClr val="FBBF24"/>
+                </a:solidFill>
+                <a:latin typeface="Malgun Gothic"/>
+              </a:defRPr>
+            </a:pPr>
+            <a:r>
+              <a:t>• [Day 7] Cloud Run 경량 CPU 배포 (예정)</a:t>
+            </a:r>
+          </a:p>
+          <a:p>
+            <a:pPr>
+              <a:spcBef>
+                <a:spcPts val="200"/>
+              </a:spcBef>
+              <a:defRPr sz="1000" b="0">
                 <a:solidFill>
                   <a:srgbClr val="CBD5E1"/>
                 </a:solidFill>
@@ -5176,15 +5743,15 @@
               </a:defRPr>
             </a:pPr>
             <a:r>
-              <a:t>• React 웹 관제 대시보드 (Day 6)</a:t>
-            </a:r>
-          </a:p>
-          <a:p>
-            <a:pPr>
-              <a:spcBef>
-                <a:spcPts val="500"/>
-              </a:spcBef>
-              <a:defRPr sz="1000">
+              <a:t>   - 0.0.0.0 &amp; PORT 컨테이너 패키징</a:t>
+            </a:r>
+          </a:p>
+          <a:p>
+            <a:pPr>
+              <a:spcBef>
+                <a:spcPts val="200"/>
+              </a:spcBef>
+              <a:defRPr sz="1000" b="0">
                 <a:solidFill>
                   <a:srgbClr val="CBD5E1"/>
                 </a:solidFill>
@@ -5192,15 +5759,15 @@
               </a:defRPr>
             </a:pPr>
             <a:r>
-              <a:t>• 컨베이어 주행 동영상 Live View</a:t>
-            </a:r>
-          </a:p>
-          <a:p>
-            <a:pPr>
-              <a:spcBef>
-                <a:spcPts val="500"/>
-              </a:spcBef>
-              <a:defRPr sz="1000">
+              <a:t>   - 로컬 JSONL 한계 극복 ➔ Cloud Storage 연동</a:t>
+            </a:r>
+          </a:p>
+          <a:p>
+            <a:pPr>
+              <a:spcBef>
+                <a:spcPts val="200"/>
+              </a:spcBef>
+              <a:defRPr sz="1000" b="0">
                 <a:solidFill>
                   <a:srgbClr val="CBD5E1"/>
                 </a:solidFill>
@@ -5208,39 +5775,7 @@
               </a:defRPr>
             </a:pPr>
             <a:r>
-              <a:t>• 실시간 프레임 Grab &amp; 마우스 ROI</a:t>
-            </a:r>
-          </a:p>
-          <a:p>
-            <a:pPr>
-              <a:spcBef>
-                <a:spcPts val="500"/>
-              </a:spcBef>
-              <a:defRPr sz="1000">
-                <a:solidFill>
-                  <a:srgbClr val="CBD5E1"/>
-                </a:solidFill>
-                <a:latin typeface="Malgun Gothic"/>
-              </a:defRPr>
-            </a:pPr>
-            <a:r>
-              <a:t>• ROI 크롭 이미지 PatchCore 검사</a:t>
-            </a:r>
-          </a:p>
-          <a:p>
-            <a:pPr>
-              <a:spcBef>
-                <a:spcPts val="500"/>
-              </a:spcBef>
-              <a:defRPr sz="1000">
-                <a:solidFill>
-                  <a:srgbClr val="CBD5E1"/>
-                </a:solidFill>
-                <a:latin typeface="Malgun Gothic"/>
-              </a:defRPr>
-            </a:pPr>
-            <a:r>
-              <a:t>• Google Cloud Run 컨테이너 배포 (Day 7)</a:t>
+              <a:t>   - HTTPS 실환경 통합 검증 및 시연</a:t>
             </a:r>
           </a:p>
         </p:txBody>
@@ -5456,7 +5991,7 @@
               </a:defRPr>
             </a:pPr>
             <a:r>
-              <a:t>1. PatchCore 미탐 한계 (Recall 50.8%)</a:t>
+              <a:t>1. PatchCore 미탐 한계 (Recall 50.79%, FN 31건)</a:t>
             </a:r>
           </a:p>
           <a:p>
@@ -5472,7 +6007,7 @@
               </a:defRPr>
             </a:pPr>
             <a:r>
-              <a:t>• 현재 한계: 현재 ResNet-18 기반 모델은 83장 테스트셋에서 미세 파손과 오염 31건을 놓침. (T06 합격 사례 존재, 모델 OK가 무결점을 보증하지 않음)</a:t>
+              <a:t>• 현재 한계: ResNet-18 기반 모델은 83장 테스트셋에서 미세 파손과 오염 31건을 미검출함 (T06 합격 사례 존재, 모델 OK != 무결점). 정밀도 100%는 83장 표본 내 지표이며, 과거 209장(46.17ms) 대비 180장(42.53ms) 차이 및 contamination FN 표기 불일치는 현황 제약으로 보존</a:t>
             </a:r>
           </a:p>
           <a:p>
@@ -5569,7 +6104,7 @@
               </a:defRPr>
             </a:pPr>
             <a:r>
-              <a:t>2. Gemini HTTP 504 및 타임아웃 이슈</a:t>
+              <a:t>2. Gemini HTTP 504 및 타임아웃 안정성 이슈</a:t>
             </a:r>
           </a:p>
           <a:p>
@@ -5585,7 +6120,7 @@
               </a:defRPr>
             </a:pPr>
             <a:r>
-              <a:t>• 현재 한계: 과거 T03 최종 JSON 요청 및 T05 3차 조사에서 HTTP 504가 발생했으며 서버 내부 원인은 UNKNOWN입니다. T03은 30초 timeout 적용 단일 재검증(최종 18.967s / 전체 24.600s)으로 PASS했으나 반복 안정성을 보장하지 않으며, T05는 조기 종료 개선 후 실서버 재검증 대기 상태입니다.</a:t>
+              <a:t>• 현재 한계: 과거 T03/T05/T06에서 HTTP 504가 발생했으며 서버 내부 원인은 UNKNOWN임. 30초 timeout 적용으로 4대 시나리오 E2E 전원 성공했으나 30초가 504의 직접 해결책인지는 미확정이며, T06은 원본 ASGI 본문 미보관으로 재구성 코드 기반 검토 한계가 남음</a:t>
             </a:r>
           </a:p>
           <a:p>
@@ -5601,7 +6136,7 @@
               </a:defRPr>
             </a:pPr>
             <a:r>
-              <a:t>• 개선 계획: 조기 종료 가드레일 정밀화, 프롬프트 압축, 비동기 작업 큐 전환, 장기 모니터링 체계 확립 필요</a:t>
+              <a:t>• 개선 계획: 조기 종료 가드레일 확립, 프롬프트 압축, 비동기 작업 큐 전환 및 장기 모니터링 체계 확립 필요</a:t>
             </a:r>
           </a:p>
         </p:txBody>
@@ -5682,7 +6217,7 @@
               </a:defRPr>
             </a:pPr>
             <a:r>
-              <a:t>3. 외부 LLM 호출 지연시간 (13.58s / 24.60s)</a:t>
+              <a:t>3. 외부 LLM 호출 지연시간 (13.58s ~ 26.37s)</a:t>
             </a:r>
           </a:p>
           <a:p>
@@ -5698,7 +6233,7 @@
               </a:defRPr>
             </a:pPr>
             <a:r>
-              <a:t>• 현재 한계: Gemini API 호출에 수십 초가 소요되어 생산 라인 초고속 동기 인라인 제어에는 부적합하며, 실제 PLC/배출기 제어는 수행하지 않음</a:t>
+              <a:t>• 현재 한계: Gemini API 호출에 수십 초가 소요되어 생산 라인 초고속 동기 인라인 제어에는 부적합하며, 실제 PLC·컨베이어·배출기 제어는 수행하지 않음 (사후 진단 보조 역할에 집중)</a:t>
             </a:r>
           </a:p>
           <a:p>
@@ -5946,7 +6481,7 @@
               </a:defRPr>
             </a:pPr>
             <a:r>
-              <a:t>✔ PatchCore: 이상 점수 산출 및 모델 판정 소견(result) 제공 (CPU 42.53ms 실시간 추론)</a:t>
+              <a:t>✔ PatchCore: 이상 점수 산출 및 모델 판정 소견(result) 제공 (개발 환경 CPU 단일 이미지 평균 42.53ms 측정, ※ 사후 진단 보조)</a:t>
             </a:r>
           </a:p>
           <a:p>
@@ -5962,7 +6497,7 @@
               </a:defRPr>
             </a:pPr>
             <a:r>
-              <a:t>✔ FastAPI: 서버 규칙 기반 최종 검사 판정(final_result: REINSPECT 분리) 확정 및 감사 추적 로그 보존</a:t>
+              <a:t>✔ FastAPI: 서버 규칙 기반 최종 검사 판정(final_result: REINSPECT 분리) 확정 및 로컬 JSONL 기록 (Cloud Run 영구 저장은 GCS 연동 과제)</a:t>
             </a:r>
           </a:p>
           <a:p>
@@ -6504,7 +7039,7 @@
               </a:defRPr>
             </a:pPr>
             <a:r>
-              <a:t>   정상 이미지 180장만으로 학습, CPU 42.53ms 고속 추론으로 결함 여부 및 점수 산출</a:t>
+              <a:t>   정상 이미지 180장만으로 학습, 개발 환경 CPU 단일 이미지 PatchCore 추론 평균 42.53ms 측정</a:t>
             </a:r>
           </a:p>
           <a:p>
@@ -6562,7 +7097,7 @@
               </a:defRPr>
             </a:pPr>
             <a:r>
-              <a:t>   Gemini가 서버 도구를 직접 호출하여 사실을 수집하고, 1:1 결정적 근거(Evidence)로 검증된 진단 보고서 작성</a:t>
+              <a:t>   Gemini가 Function Calling으로 조회를 요청하면, 서버가 허용된 Python 도구를 검증·실행하여 실제 검사 근거를 수집</a:t>
             </a:r>
           </a:p>
           <a:p>
@@ -6815,7 +7350,7 @@
               <a:spcBef>
                 <a:spcPts val="300"/>
               </a:spcBef>
-              <a:defRPr sz="1000">
+              <a:defRPr sz="950">
                 <a:solidFill>
                   <a:srgbClr val="F8FAFC"/>
                 </a:solidFill>
@@ -6823,7 +7358,7 @@
               </a:defRPr>
             </a:pPr>
             <a:r>
-              <a:t>• OpenCV 이미지 전처리 &amp; 품질 분석 (밝기 81.24/135.86 등)   • PatchCore Anomaly Detection Engine (ResNet-18)   • CPU 단일 이미지 평균 추론: 42.53ms 달성 (실시간성 확보)</a:t>
+              <a:t>• OpenCV 이미지 전처리 &amp; 품질 분석 (밝기 81.24/135.86 등)   • PatchCore Anomaly Detection Engine (ResNet-18)   • 개발 환경 CPU 단일 이미지 PatchCore 추론 평균: 42.53ms 측정 (※ 순수 모델 추론 시간)</a:t>
             </a:r>
           </a:p>
         </p:txBody>
@@ -6912,7 +7447,7 @@
               <a:spcBef>
                 <a:spcPts val="300"/>
               </a:spcBef>
-              <a:defRPr sz="1000">
+              <a:defRPr sz="950">
                 <a:solidFill>
                   <a:srgbClr val="F8FAFC"/>
                 </a:solidFill>
@@ -7009,7 +7544,7 @@
               <a:spcBef>
                 <a:spcPts val="300"/>
               </a:spcBef>
-              <a:defRPr sz="1000">
+              <a:defRPr sz="950">
                 <a:solidFill>
                   <a:srgbClr val="F8FAFC"/>
                 </a:solidFill>
@@ -7017,7 +7552,7 @@
               </a:defRPr>
             </a:pPr>
             <a:r>
-              <a:t>• 불변 검사 로그 및 시각순 감사 로그(events.jsonl) 영구 기록   • 도구 실행 시 고유 Evidence ID(E0001, E0002) 자동 발급   • 원본 정답(Ground Truth)과 운영 데이터의 엄격한 격리</a:t>
+              <a:t>• 검사 결과(data/inspections.jsonl) 및 실행 이벤트(data/inspection_logs.jsonl) 로컬 기록   • inspection_id 기반 추적 및 Evidence ID(E0001, E0002) 자동 발급   • 평가 Ground Truth와 운영 데이터 엄격 분리 (※ 로컬 저장은 개발용, Cloud Run 영구 저장은 GCS 연동 과제)</a:t>
             </a:r>
           </a:p>
         </p:txBody>
@@ -7106,7 +7641,7 @@
               <a:spcBef>
                 <a:spcPts val="300"/>
               </a:spcBef>
-              <a:defRPr sz="1000">
+              <a:defRPr sz="950">
                 <a:solidFill>
                   <a:srgbClr val="F8FAFC"/>
                 </a:solidFill>
@@ -7114,7 +7649,7 @@
               </a:defRPr>
             </a:pPr>
             <a:r>
-              <a:t>• Gemini 3.8 Flash Function Calling 기반 심층 진단   • 도구 호출 ➔ 결과 수집 ➔ 토큰 카탈로그 기반 단순 JSON 생성   • Python 결정적 Evidence 검증 통과 보고서만 운영자에게 제공</a:t>
+              <a:t>• Gemini 3.8 Flash Function Calling 기반 사후 원인 진단 보조   • Gemini가 도구 제안 ➔ 서버 인자 검증 후 Python 도구 실행 ➔ 단순 JSON 생성   • Python 결정적 Evidence 검증 통과 보고서만 운영자에게 제공</a:t>
             </a:r>
           </a:p>
         </p:txBody>
@@ -7336,9 +7871,9 @@
           <a:p>
             <a:pPr>
               <a:spcBef>
-                <a:spcPts val="800"/>
-              </a:spcBef>
-              <a:defRPr sz="1200" b="1">
+                <a:spcPts val="600"/>
+              </a:spcBef>
+              <a:defRPr sz="1150" b="1">
                 <a:solidFill>
                   <a:srgbClr val="F8FAFC"/>
                 </a:solidFill>
@@ -7351,7 +7886,7 @@
           </a:p>
           <a:p>
             <a:pPr>
-              <a:defRPr sz="950">
+              <a:defRPr sz="900">
                 <a:solidFill>
                   <a:srgbClr val="94A3B8"/>
                 </a:solidFill>
@@ -7359,15 +7894,15 @@
               </a:defRPr>
             </a:pPr>
             <a:r>
-              <a:t>   (비지도 학습 수행)</a:t>
-            </a:r>
-          </a:p>
-          <a:p>
-            <a:pPr>
-              <a:spcBef>
-                <a:spcPts val="800"/>
-              </a:spcBef>
-              <a:defRPr sz="1200" b="1">
+              <a:t>   (비지도 Coreset 서브샘플링)</a:t>
+            </a:r>
+          </a:p>
+          <a:p>
+            <a:pPr>
+              <a:spcBef>
+                <a:spcPts val="600"/>
+              </a:spcBef>
+              <a:defRPr sz="1150" b="1">
                 <a:solidFill>
                   <a:srgbClr val="F8FAFC"/>
                 </a:solidFill>
@@ -7375,12 +7910,12 @@
               </a:defRPr>
             </a:pPr>
             <a:r>
-              <a:t>임계값 산출셋: 정상 이미지 29장</a:t>
-            </a:r>
-          </a:p>
-          <a:p>
-            <a:pPr>
-              <a:defRPr sz="950">
+              <a:t>임계값 산출셋: 독립 정상 이미지 29장</a:t>
+            </a:r>
+          </a:p>
+          <a:p>
+            <a:pPr>
+              <a:defRPr sz="900">
                 <a:solidFill>
                   <a:srgbClr val="94A3B8"/>
                 </a:solidFill>
@@ -7388,15 +7923,15 @@
               </a:defRPr>
             </a:pPr>
             <a:r>
-              <a:t>   (분포 기반 임계값 산출)</a:t>
-            </a:r>
-          </a:p>
-          <a:p>
-            <a:pPr>
-              <a:spcBef>
-                <a:spcPts val="800"/>
-              </a:spcBef>
-              <a:defRPr sz="1200" b="1">
+              <a:t>   (분포 기반 임계값 산출 (mu + 3sigma))</a:t>
+            </a:r>
+          </a:p>
+          <a:p>
+            <a:pPr>
+              <a:spcBef>
+                <a:spcPts val="600"/>
+              </a:spcBef>
+              <a:defRPr sz="1150" b="1">
                 <a:solidFill>
                   <a:srgbClr val="F8FAFC"/>
                 </a:solidFill>
@@ -7409,7 +7944,7 @@
           </a:p>
           <a:p>
             <a:pPr>
-              <a:defRPr sz="950">
+              <a:defRPr sz="900">
                 <a:solidFill>
                   <a:srgbClr val="94A3B8"/>
                 </a:solidFill>
@@ -7423,9 +7958,9 @@
           <a:p>
             <a:pPr>
               <a:spcBef>
-                <a:spcPts val="800"/>
-              </a:spcBef>
-              <a:defRPr sz="1200" b="1">
+                <a:spcPts val="600"/>
+              </a:spcBef>
+              <a:defRPr sz="1150" b="1">
                 <a:solidFill>
                   <a:srgbClr val="F8FAFC"/>
                 </a:solidFill>
@@ -7438,7 +7973,7 @@
           </a:p>
           <a:p>
             <a:pPr>
-              <a:defRPr sz="950">
+              <a:defRPr sz="900">
                 <a:solidFill>
                   <a:srgbClr val="94A3B8"/>
                 </a:solidFill>
@@ -7446,15 +7981,15 @@
               </a:defRPr>
             </a:pPr>
             <a:r>
-              <a:t>   (공식 평가셋)</a:t>
-            </a:r>
-          </a:p>
-          <a:p>
-            <a:pPr>
-              <a:spcBef>
-                <a:spcPts val="800"/>
-              </a:spcBef>
-              <a:defRPr sz="1200" b="1">
+              <a:t>   (공식 평가셋 표본 기준)</a:t>
+            </a:r>
+          </a:p>
+          <a:p>
+            <a:pPr>
+              <a:spcBef>
+                <a:spcPts val="600"/>
+              </a:spcBef>
+              <a:defRPr sz="1150" b="1">
                 <a:solidFill>
                   <a:srgbClr val="F8FAFC"/>
                 </a:solidFill>
@@ -7467,7 +8002,7 @@
           </a:p>
           <a:p>
             <a:pPr>
-              <a:defRPr sz="950">
+              <a:defRPr sz="900">
                 <a:solidFill>
                   <a:srgbClr val="94A3B8"/>
                 </a:solidFill>
@@ -7481,9 +8016,9 @@
           <a:p>
             <a:pPr>
               <a:spcBef>
-                <a:spcPts val="800"/>
-              </a:spcBef>
-              <a:defRPr sz="1200" b="1">
+                <a:spcPts val="600"/>
+              </a:spcBef>
+              <a:defRPr sz="1150" b="1">
                 <a:solidFill>
                   <a:srgbClr val="F8FAFC"/>
                 </a:solidFill>
@@ -7491,12 +8026,12 @@
               </a:defRPr>
             </a:pPr>
             <a:r>
-              <a:t>정밀도 (Precision): 100.0%</a:t>
-            </a:r>
-          </a:p>
-          <a:p>
-            <a:pPr>
-              <a:defRPr sz="950">
+              <a:t>정밀도 (Precision): 100.0% (83장 표본 한정)</a:t>
+            </a:r>
+          </a:p>
+          <a:p>
+            <a:pPr>
+              <a:defRPr sz="900">
                 <a:solidFill>
                   <a:srgbClr val="94A3B8"/>
                 </a:solidFill>
@@ -7504,15 +8039,15 @@
               </a:defRPr>
             </a:pPr>
             <a:r>
-              <a:t>   (검출 불량 중 실제 불량 비율)</a:t>
-            </a:r>
-          </a:p>
-          <a:p>
-            <a:pPr>
-              <a:spcBef>
-                <a:spcPts val="800"/>
-              </a:spcBef>
-              <a:defRPr sz="1200" b="1">
+              <a:t>   (해당 표본 기준 실측 (실전 전수 보장 아님))</a:t>
+            </a:r>
+          </a:p>
+          <a:p>
+            <a:pPr>
+              <a:spcBef>
+                <a:spcPts val="600"/>
+              </a:spcBef>
+              <a:defRPr sz="1150" b="1">
                 <a:solidFill>
                   <a:srgbClr val="F8FAFC"/>
                 </a:solidFill>
@@ -7520,12 +8055,12 @@
               </a:defRPr>
             </a:pPr>
             <a:r>
-              <a:t>재현율 (Recall): 50.79%</a:t>
-            </a:r>
-          </a:p>
-          <a:p>
-            <a:pPr>
-              <a:defRPr sz="950">
+              <a:t>재현율 (Recall): 50.79% (미탐 31건 발생)</a:t>
+            </a:r>
+          </a:p>
+          <a:p>
+            <a:pPr>
+              <a:defRPr sz="900">
                 <a:solidFill>
                   <a:srgbClr val="94A3B8"/>
                 </a:solidFill>
@@ -7533,15 +8068,15 @@
               </a:defRPr>
             </a:pPr>
             <a:r>
-              <a:t>   (전체 63건 중 32건 탐지)</a:t>
-            </a:r>
-          </a:p>
-          <a:p>
-            <a:pPr>
-              <a:spcBef>
-                <a:spcPts val="800"/>
-              </a:spcBef>
-              <a:defRPr sz="1200" b="1">
+              <a:t>   (실제 불량 63건 중 32건 탐지, 31건 미탐)</a:t>
+            </a:r>
+          </a:p>
+          <a:p>
+            <a:pPr>
+              <a:spcBef>
+                <a:spcPts val="600"/>
+              </a:spcBef>
+              <a:defRPr sz="1150" b="1">
                 <a:solidFill>
                   <a:srgbClr val="F8FAFC"/>
                 </a:solidFill>
@@ -7549,12 +8084,12 @@
               </a:defRPr>
             </a:pPr>
             <a:r>
-              <a:t>단일 이미지 추론 시간: CPU 평균 42.53ms</a:t>
-            </a:r>
-          </a:p>
-          <a:p>
-            <a:pPr>
-              <a:defRPr sz="950">
+              <a:t>CPU 단일 추론 시간: 평균 42.53ms (PatchCore만)</a:t>
+            </a:r>
+          </a:p>
+          <a:p>
+            <a:pPr>
+              <a:defRPr sz="900">
                 <a:solidFill>
                   <a:srgbClr val="94A3B8"/>
                 </a:solidFill>
@@ -7562,7 +8097,7 @@
               </a:defRPr>
             </a:pPr>
             <a:r>
-              <a:t>   (Intel Core i7-14700F)</a:t>
+              <a:t>   (Agent 전체나 라인 처리속도 아님)</a:t>
             </a:r>
           </a:p>
         </p:txBody>
@@ -7649,9 +8184,9 @@
           <a:p>
             <a:pPr>
               <a:spcBef>
-                <a:spcPts val="600"/>
-              </a:spcBef>
-              <a:defRPr sz="1150" b="1">
+                <a:spcPts val="500"/>
+              </a:spcBef>
+              <a:defRPr sz="1100" b="1">
                 <a:solidFill>
                   <a:srgbClr val="F8FAFC"/>
                 </a:solidFill>
@@ -7659,12 +8194,12 @@
               </a:defRPr>
             </a:pPr>
             <a:r>
-              <a:t>• 진양성 (TP): 32건</a:t>
-            </a:r>
-          </a:p>
-          <a:p>
-            <a:pPr>
-              <a:defRPr sz="950">
+              <a:t>• 진양성 (TP): 32건 / 진음성 (TN): 20건</a:t>
+            </a:r>
+          </a:p>
+          <a:p>
+            <a:pPr>
+              <a:defRPr sz="900">
                 <a:solidFill>
                   <a:srgbClr val="CBD5E1"/>
                 </a:solidFill>
@@ -7672,15 +8207,15 @@
               </a:defRPr>
             </a:pPr>
             <a:r>
-              <a:t>   실제 결함 63건 중 32건을 정확히 NG로 검출</a:t>
-            </a:r>
-          </a:p>
-          <a:p>
-            <a:pPr>
-              <a:spcBef>
-                <a:spcPts val="600"/>
-              </a:spcBef>
-              <a:defRPr sz="1150" b="1">
+              <a:t>   실제 결함 32건 검출, 정상 제품 20건 정상 판정</a:t>
+            </a:r>
+          </a:p>
+          <a:p>
+            <a:pPr>
+              <a:spcBef>
+                <a:spcPts val="500"/>
+              </a:spcBef>
+              <a:defRPr sz="1100" b="1">
                 <a:solidFill>
                   <a:srgbClr val="F8FAFC"/>
                 </a:solidFill>
@@ -7688,12 +8223,12 @@
               </a:defRPr>
             </a:pPr>
             <a:r>
-              <a:t>• 위양성 (FP): 0건</a:t>
-            </a:r>
-          </a:p>
-          <a:p>
-            <a:pPr>
-              <a:defRPr sz="950">
+              <a:t>• 위양성 (FP): 0건 (정밀도 100%)</a:t>
+            </a:r>
+          </a:p>
+          <a:p>
+            <a:pPr>
+              <a:defRPr sz="900">
                 <a:solidFill>
                   <a:srgbClr val="CBD5E1"/>
                 </a:solidFill>
@@ -7701,15 +8236,15 @@
               </a:defRPr>
             </a:pPr>
             <a:r>
-              <a:t>   정상 제품 20건 중 오판 0건 (정밀도 100% 달성)</a:t>
-            </a:r>
-          </a:p>
-          <a:p>
-            <a:pPr>
-              <a:spcBef>
-                <a:spcPts val="600"/>
-              </a:spcBef>
-              <a:defRPr sz="1150" b="1">
+              <a:t>   83장 표본 내 과검 0건 (모든 공정의 FP 0% 보장 아님)</a:t>
+            </a:r>
+          </a:p>
+          <a:p>
+            <a:pPr>
+              <a:spcBef>
+                <a:spcPts val="500"/>
+              </a:spcBef>
+              <a:defRPr sz="1100" b="1">
                 <a:solidFill>
                   <a:srgbClr val="F8FAFC"/>
                 </a:solidFill>
@@ -7717,12 +8252,12 @@
               </a:defRPr>
             </a:pPr>
             <a:r>
-              <a:t>• 진음성 (TN): 20건</a:t>
-            </a:r>
-          </a:p>
-          <a:p>
-            <a:pPr>
-              <a:defRPr sz="950">
+              <a:t>• 위음성 (FN): 31건 (재현율 50.79%)</a:t>
+            </a:r>
+          </a:p>
+          <a:p>
+            <a:pPr>
+              <a:defRPr sz="900">
                 <a:solidFill>
                   <a:srgbClr val="CBD5E1"/>
                 </a:solidFill>
@@ -7730,15 +8265,15 @@
               </a:defRPr>
             </a:pPr>
             <a:r>
-              <a:t>   정상 제품 20건을 모두 정상(OK)으로 판정</a:t>
-            </a:r>
-          </a:p>
-          <a:p>
-            <a:pPr>
-              <a:spcBef>
-                <a:spcPts val="600"/>
-              </a:spcBef>
-              <a:defRPr sz="1150" b="1">
+              <a:t>   미세 결함 31건 미탐지 (모델 OK != 무결점 제품)</a:t>
+            </a:r>
+          </a:p>
+          <a:p>
+            <a:pPr>
+              <a:spcBef>
+                <a:spcPts val="500"/>
+              </a:spcBef>
+              <a:defRPr sz="1100" b="1">
                 <a:solidFill>
                   <a:srgbClr val="F8FAFC"/>
                 </a:solidFill>
@@ -7746,12 +8281,12 @@
               </a:defRPr>
             </a:pPr>
             <a:r>
-              <a:t>• 위음성 (FN): 31건</a:t>
-            </a:r>
-          </a:p>
-          <a:p>
-            <a:pPr>
-              <a:defRPr sz="950">
+              <a:t>• T06 미탐 사례 보존</a:t>
+            </a:r>
+          </a:p>
+          <a:p>
+            <a:pPr>
+              <a:defRPr sz="900">
                 <a:solidFill>
                   <a:srgbClr val="CBD5E1"/>
                 </a:solidFill>
@@ -7759,15 +8294,15 @@
               </a:defRPr>
             </a:pPr>
             <a:r>
-              <a:t>   미세 결함 31건을 미탐지 (엔지니어링 한계 인식)</a:t>
-            </a:r>
-          </a:p>
-          <a:p>
-            <a:pPr>
-              <a:spcBef>
-                <a:spcPts val="600"/>
-              </a:spcBef>
-              <a:defRPr sz="1150" b="1">
+              <a:t>   파손 불량 T06이 점수 32.27로 합격 처리된 한계 보존</a:t>
+            </a:r>
+          </a:p>
+          <a:p>
+            <a:pPr>
+              <a:spcBef>
+                <a:spcPts val="500"/>
+              </a:spcBef>
+              <a:defRPr sz="1100" b="1">
                 <a:solidFill>
                   <a:srgbClr val="F8FAFC"/>
                 </a:solidFill>
@@ -7775,12 +8310,12 @@
               </a:defRPr>
             </a:pPr>
             <a:r>
-              <a:t>• T06 미탐 사례 보존</a:t>
-            </a:r>
-          </a:p>
-          <a:p>
-            <a:pPr>
-              <a:defRPr sz="950">
+              <a:t>• 평가 문서 제약 보존</a:t>
+            </a:r>
+          </a:p>
+          <a:p>
+            <a:pPr>
+              <a:defRPr sz="900">
                 <a:solidFill>
                   <a:srgbClr val="CBD5E1"/>
                 </a:solidFill>
@@ -7788,15 +8323,15 @@
               </a:defRPr>
             </a:pPr>
             <a:r>
-              <a:t>   파손 불량 T06이 점수 32.27로 합격 처리된 한계 보존</a:t>
-            </a:r>
-          </a:p>
-          <a:p>
-            <a:pPr>
-              <a:spcBef>
-                <a:spcPts val="600"/>
-              </a:spcBef>
-              <a:defRPr sz="1150" b="1">
+              <a:t>   과거 209장(46.17ms) 모델 대비 현재 180장(42.53ms) 차이 및 contamination FN 표기 불일치는 현황 제약으로 보존</a:t>
+            </a:r>
+          </a:p>
+          <a:p>
+            <a:pPr>
+              <a:spcBef>
+                <a:spcPts val="500"/>
+              </a:spcBef>
+              <a:defRPr sz="1100" b="1">
                 <a:solidFill>
                   <a:srgbClr val="F8FAFC"/>
                 </a:solidFill>
@@ -7804,12 +8339,12 @@
               </a:defRPr>
             </a:pPr>
             <a:r>
-              <a:t>• 안전 규칙 준수</a:t>
-            </a:r>
-          </a:p>
-          <a:p>
-            <a:pPr>
-              <a:defRPr sz="950">
+              <a:t>• 정답 격리 &amp; 설비 미제어</a:t>
+            </a:r>
+          </a:p>
+          <a:p>
+            <a:pPr>
+              <a:defRPr sz="900">
                 <a:solidFill>
                   <a:srgbClr val="CBD5E1"/>
                 </a:solidFill>
@@ -7817,7 +8352,7 @@
               </a:defRPr>
             </a:pPr>
             <a:r>
-              <a:t>   실제 정답 라벨은 Agent에 일절 미제공 (평가 격리 유지)</a:t>
+              <a:t>   실제 정답 라벨은 Agent에 미제공, 물리적 PLC 제어 미수행</a:t>
             </a:r>
           </a:p>
         </p:txBody>
@@ -9677,7 +10212,7 @@
               </a:defRPr>
             </a:pPr>
             <a:r>
-              <a:t>💡 실제 실서버 검증 성과: T01의 관측 사실 6개와 T03의 관측 사실 12개가 서버의 Evidence 검증을 통과했습니다. (서버에 등록된 필드에 대해 엄밀한 1:1 결정적 일치를 확인하며, 모든 자연어 가설이나 미래의 출력을 완전 검증한다고 과장하지 않음)</a:t>
+              <a:t>💡 실제 실서버 검증 성과: 4대 대표 시나리오 T01(6개), T03(12개), T05(17개), T06(6개)의 관측 사실 전원이 서버의 Evidence 및 JSON Pointer 검증을 통과했습니다. (서버 등록 필드 1:1 결정적 일치를 확인하며, 모든 자연어 가설을 완전 검증한다고 과장하지 않음)</a:t>
             </a:r>
           </a:p>
         </p:txBody>
@@ -10591,7 +11126,7 @@
               <a:spcBef>
                 <a:spcPts val="100"/>
               </a:spcBef>
-              <a:defRPr sz="1200" b="1">
+              <a:defRPr sz="1150" b="1">
                 <a:solidFill>
                   <a:srgbClr val="34D399"/>
                 </a:solidFill>
@@ -10599,7 +11134,7 @@
               </a:defRPr>
             </a:pPr>
             <a:r>
-              <a:t>T01/T03 실제 E2E PASS</a:t>
+              <a:t>대표 4개 시나리오 E2E 성공 회차 확보</a:t>
             </a:r>
           </a:p>
           <a:p>
@@ -10612,7 +11147,7 @@
               </a:defRPr>
             </a:pPr>
             <a:r>
-              <a:t>실제 Gemini 통신 완전 성공 및 무오류 수락</a:t>
+              <a:t>단순 JSON 스키마 적용 ➔ Python 엄격 검증 통과</a:t>
             </a:r>
           </a:p>
         </p:txBody>
@@ -10709,7 +11244,7 @@
               </a:defRPr>
             </a:pPr>
             <a:r>
-              <a:t>최종 JSON 생성 지연</a:t>
+              <a:t>타임아웃 분리 및 계측</a:t>
             </a:r>
           </a:p>
           <a:p>
@@ -10741,7 +11276,7 @@
               </a:defRPr>
             </a:pPr>
             <a:r>
-              <a:t>T03 최종 JSON 요청 HTTP 504</a:t>
+              <a:t>과거 T03/T06 최종 생성 15s 초과 504 발생</a:t>
             </a:r>
           </a:p>
           <a:p>
@@ -10754,7 +11289,7 @@
               </a:defRPr>
             </a:pPr>
             <a:r>
-              <a:t>*(15초 제한 초과 발생, 서버 내부 원인 UNKNOWN)</a:t>
+              <a:t>*(서버 내부 원인은 UNKNOWN, 반복 안정성 과제)</a:t>
             </a:r>
           </a:p>
           <a:p>
@@ -10823,7 +11358,7 @@
               <a:spcBef>
                 <a:spcPts val="100"/>
               </a:spcBef>
-              <a:defRPr sz="1200" b="1">
+              <a:defRPr sz="1150" b="1">
                 <a:solidFill>
                   <a:srgbClr val="34D399"/>
                 </a:solidFill>
@@ -10831,7 +11366,7 @@
               </a:defRPr>
             </a:pPr>
             <a:r>
-              <a:t>최종 요청 18.967초 / 전체 24.600초 PASS</a:t>
+              <a:t>T03(18.97s) &amp; T06(24.12s) PASS</a:t>
             </a:r>
           </a:p>
           <a:p>
@@ -10844,7 +11379,7 @@
               </a:defRPr>
             </a:pPr>
             <a:r>
-              <a:t>단일 실측치 (반복 안정성 보장 아님, 대본 보존)</a:t>
+              <a:t>선택적 30초 설정 회차 성공 (504 직접 해결은 미확정)</a:t>
             </a:r>
           </a:p>
         </p:txBody>
@@ -10868,7 +11403,7 @@
           </a:solidFill>
           <a:ln w="12700">
             <a:solidFill>
-              <a:srgbClr val="F87171"/>
+              <a:srgbClr val="34D399"/>
             </a:solidFill>
           </a:ln>
         </p:spPr>
@@ -10919,13 +11454,13 @@
             <a:pPr>
               <a:defRPr sz="1100" b="1">
                 <a:solidFill>
-                  <a:srgbClr val="F87171"/>
-                </a:solidFill>
-                <a:latin typeface="Malgun Gothic"/>
-              </a:defRPr>
-            </a:pPr>
-            <a:r>
-              <a:t>T05 ERROR</a:t>
+                  <a:srgbClr val="34D399"/>
+                </a:solidFill>
+                <a:latin typeface="Malgun Gothic"/>
+              </a:defRPr>
+            </a:pPr>
+            <a:r>
+              <a:t>E2E 완결</a:t>
             </a:r>
           </a:p>
           <a:p>
@@ -10941,7 +11476,7 @@
               </a:defRPr>
             </a:pPr>
             <a:r>
-              <a:t>조기 종료 및 근거 검증</a:t>
+              <a:t>T05 조기종료 &amp; T06 불변성</a:t>
             </a:r>
           </a:p>
           <a:p>
@@ -10951,7 +11486,7 @@
               </a:spcBef>
               <a:defRPr sz="1100" b="1">
                 <a:solidFill>
-                  <a:srgbClr val="F87171"/>
+                  <a:srgbClr val="34D399"/>
                 </a:solidFill>
                 <a:latin typeface="Malgun Gothic"/>
               </a:defRPr>
@@ -10973,7 +11508,7 @@
               </a:defRPr>
             </a:pPr>
             <a:r>
-              <a:t>필수 근거 확보 후 불필요 추가 조사 발생</a:t>
+              <a:t>T05 3차조사 504 FAIL &amp; T06 정답 격리</a:t>
             </a:r>
           </a:p>
           <a:p>
@@ -10986,7 +11521,7 @@
               </a:defRPr>
             </a:pPr>
             <a:r>
-              <a:t>*(기존 실서버 1회 FAIL: 3차 조사 504, 원인 UNKNOWN)</a:t>
+              <a:t>*(T05 1회 FAIL 보존, T06 외부 정답 미제공)</a:t>
             </a:r>
           </a:p>
           <a:p>
@@ -10996,7 +11531,7 @@
               </a:spcBef>
               <a:defRPr sz="1100" b="1">
                 <a:solidFill>
-                  <a:srgbClr val="F87171"/>
+                  <a:srgbClr val="34D399"/>
                 </a:solidFill>
                 <a:latin typeface="Malgun Gothic"/>
               </a:defRPr>
@@ -11018,7 +11553,7 @@
               </a:defRPr>
             </a:pPr>
             <a:r>
-              <a:t>조기 종료 정책 + 계측기 WARNING 정합화</a:t>
+              <a:t>T05 전용 조기 종료 &amp; T06 판정 가드레일</a:t>
             </a:r>
           </a:p>
           <a:p>
@@ -11031,7 +11566,7 @@
               </a:defRPr>
             </a:pPr>
             <a:r>
-              <a:t>*(도구 2회+17개 사실 확보 후 즉시 최종 전환)</a:t>
+              <a:t>*(17개 사실 즉시종료, final_result=OK 불변)</a:t>
             </a:r>
           </a:p>
           <a:p>
@@ -11041,7 +11576,7 @@
               </a:spcBef>
               <a:defRPr sz="1100" b="1">
                 <a:solidFill>
-                  <a:srgbClr val="FBBF24"/>
+                  <a:srgbClr val="34D399"/>
                 </a:solidFill>
                 <a:latin typeface="Malgun Gothic"/>
               </a:defRPr>
@@ -11055,15 +11590,15 @@
               <a:spcBef>
                 <a:spcPts val="100"/>
               </a:spcBef>
-              <a:defRPr sz="1200" b="1">
-                <a:solidFill>
-                  <a:srgbClr val="FBBF24"/>
-                </a:solidFill>
-                <a:latin typeface="Malgun Gothic"/>
-              </a:defRPr>
-            </a:pPr>
-            <a:r>
-              <a:t>Mock PASS / 실서버 재검증 대기</a:t>
+              <a:defRPr sz="1150" b="1">
+                <a:solidFill>
+                  <a:srgbClr val="34D399"/>
+                </a:solidFill>
+                <a:latin typeface="Malgun Gothic"/>
+              </a:defRPr>
+            </a:pPr>
+            <a:r>
+              <a:t>T05(16.33s) &amp; T06(26.37s) PASS</a:t>
             </a:r>
           </a:p>
           <a:p>
@@ -11076,7 +11611,7 @@
               </a:defRPr>
             </a:pPr>
             <a:r>
-              <a:t>전체 pytest 984 PASS (경고 3건) / 조기 종료 통과</a:t>
+              <a:t>T06 원본 ASGI 미보관 (재구성 코드 기반 검토 한계)</a:t>
             </a:r>
           </a:p>
         </p:txBody>
@@ -11157,7 +11692,7 @@
               </a:defRPr>
             </a:pPr>
             <a:r>
-              <a:t>💡 현황: T05 기존 실서버 E2E 1회 FAIL(후속 조사 HTTP 504) → 조기 종료 개선 후 오프라인 PASS, 실서버 재검증 대기 | 전체 pytest 984 PASS</a:t>
+              <a:t>💡 현황: T01·T03·T05·T06 대표 4개 시나리오에서 각각 실제 Gemini E2E 성공 회차 확보 (단일 성공 회차가 반복 실행 안정성을 보증하는 것은 아님) | 전체 pytest 1089 PASS / 4 SKIP</a:t>
             </a:r>
           </a:p>
         </p:txBody>

</xml_diff>